<commit_message>
add one more fig to step1
</commit_message>
<xml_diff>
--- a/Reports/Step1/figures.pptx
+++ b/Reports/Step1/figures.pptx
@@ -8,6 +8,7 @@
     <p:sldId id="256" r:id="rId2"/>
     <p:sldId id="257" r:id="rId3"/>
     <p:sldId id="258" r:id="rId4"/>
+    <p:sldId id="259" r:id="rId5"/>
   </p:sldIdLst>
   <p:sldSz cx="12192000" cy="6858000"/>
   <p:notesSz cx="6858000" cy="9144000"/>
@@ -106,6 +107,11 @@
       </a:defRPr>
     </a:lvl9pPr>
   </p:defaultTextStyle>
+  <p:extLst>
+    <p:ext uri="{EFAFB233-063F-42B5-8137-9DF3F51BA10A}">
+      <p15:sldGuideLst xmlns:p15="http://schemas.microsoft.com/office/powerpoint/2012/main"/>
+    </p:ext>
+  </p:extLst>
 </p:presentation>
 </file>
 
@@ -256,7 +262,7 @@
           <a:p>
             <a:fld id="{070C54B2-02AF-4F32-9526-487D6CDB273B}" type="datetimeFigureOut">
               <a:rPr lang="en-US" smtClean="0"/>
-              <a:t>9/16/2025</a:t>
+              <a:t>9/22/2025</a:t>
             </a:fld>
             <a:endParaRPr lang="en-US"/>
           </a:p>
@@ -454,7 +460,7 @@
           <a:p>
             <a:fld id="{070C54B2-02AF-4F32-9526-487D6CDB273B}" type="datetimeFigureOut">
               <a:rPr lang="en-US" smtClean="0"/>
-              <a:t>9/16/2025</a:t>
+              <a:t>9/22/2025</a:t>
             </a:fld>
             <a:endParaRPr lang="en-US"/>
           </a:p>
@@ -662,7 +668,7 @@
           <a:p>
             <a:fld id="{070C54B2-02AF-4F32-9526-487D6CDB273B}" type="datetimeFigureOut">
               <a:rPr lang="en-US" smtClean="0"/>
-              <a:t>9/16/2025</a:t>
+              <a:t>9/22/2025</a:t>
             </a:fld>
             <a:endParaRPr lang="en-US"/>
           </a:p>
@@ -860,7 +866,7 @@
           <a:p>
             <a:fld id="{070C54B2-02AF-4F32-9526-487D6CDB273B}" type="datetimeFigureOut">
               <a:rPr lang="en-US" smtClean="0"/>
-              <a:t>9/16/2025</a:t>
+              <a:t>9/22/2025</a:t>
             </a:fld>
             <a:endParaRPr lang="en-US"/>
           </a:p>
@@ -1135,7 +1141,7 @@
           <a:p>
             <a:fld id="{070C54B2-02AF-4F32-9526-487D6CDB273B}" type="datetimeFigureOut">
               <a:rPr lang="en-US" smtClean="0"/>
-              <a:t>9/16/2025</a:t>
+              <a:t>9/22/2025</a:t>
             </a:fld>
             <a:endParaRPr lang="en-US"/>
           </a:p>
@@ -1400,7 +1406,7 @@
           <a:p>
             <a:fld id="{070C54B2-02AF-4F32-9526-487D6CDB273B}" type="datetimeFigureOut">
               <a:rPr lang="en-US" smtClean="0"/>
-              <a:t>9/16/2025</a:t>
+              <a:t>9/22/2025</a:t>
             </a:fld>
             <a:endParaRPr lang="en-US"/>
           </a:p>
@@ -1812,7 +1818,7 @@
           <a:p>
             <a:fld id="{070C54B2-02AF-4F32-9526-487D6CDB273B}" type="datetimeFigureOut">
               <a:rPr lang="en-US" smtClean="0"/>
-              <a:t>9/16/2025</a:t>
+              <a:t>9/22/2025</a:t>
             </a:fld>
             <a:endParaRPr lang="en-US"/>
           </a:p>
@@ -1953,7 +1959,7 @@
           <a:p>
             <a:fld id="{070C54B2-02AF-4F32-9526-487D6CDB273B}" type="datetimeFigureOut">
               <a:rPr lang="en-US" smtClean="0"/>
-              <a:t>9/16/2025</a:t>
+              <a:t>9/22/2025</a:t>
             </a:fld>
             <a:endParaRPr lang="en-US"/>
           </a:p>
@@ -2066,7 +2072,7 @@
           <a:p>
             <a:fld id="{070C54B2-02AF-4F32-9526-487D6CDB273B}" type="datetimeFigureOut">
               <a:rPr lang="en-US" smtClean="0"/>
-              <a:t>9/16/2025</a:t>
+              <a:t>9/22/2025</a:t>
             </a:fld>
             <a:endParaRPr lang="en-US"/>
           </a:p>
@@ -2377,7 +2383,7 @@
           <a:p>
             <a:fld id="{070C54B2-02AF-4F32-9526-487D6CDB273B}" type="datetimeFigureOut">
               <a:rPr lang="en-US" smtClean="0"/>
-              <a:t>9/16/2025</a:t>
+              <a:t>9/22/2025</a:t>
             </a:fld>
             <a:endParaRPr lang="en-US"/>
           </a:p>
@@ -2665,7 +2671,7 @@
           <a:p>
             <a:fld id="{070C54B2-02AF-4F32-9526-487D6CDB273B}" type="datetimeFigureOut">
               <a:rPr lang="en-US" smtClean="0"/>
-              <a:t>9/16/2025</a:t>
+              <a:t>9/22/2025</a:t>
             </a:fld>
             <a:endParaRPr lang="en-US"/>
           </a:p>
@@ -2906,7 +2912,7 @@
           <a:p>
             <a:fld id="{070C54B2-02AF-4F32-9526-487D6CDB273B}" type="datetimeFigureOut">
               <a:rPr lang="en-US" smtClean="0"/>
-              <a:t>9/16/2025</a:t>
+              <a:t>9/22/2025</a:t>
             </a:fld>
             <a:endParaRPr lang="en-US"/>
           </a:p>
@@ -4358,6 +4364,225 @@
 </p:sld>
 </file>
 
+<file path=ppt/slides/slide4.xml><?xml version="1.0" encoding="utf-8"?>
+<p:sld xmlns:a="http://schemas.openxmlformats.org/drawingml/2006/main" xmlns:r="http://schemas.openxmlformats.org/officeDocument/2006/relationships" xmlns:p="http://schemas.openxmlformats.org/presentationml/2006/main">
+  <p:cSld>
+    <p:bg>
+      <p:bgPr>
+        <a:solidFill>
+          <a:schemeClr val="bg1"/>
+        </a:solidFill>
+        <a:effectLst/>
+      </p:bgPr>
+    </p:bg>
+    <p:spTree>
+      <p:nvGrpSpPr>
+        <p:cNvPr id="1" name="">
+          <a:extLst>
+            <a:ext uri="{FF2B5EF4-FFF2-40B4-BE49-F238E27FC236}">
+              <a16:creationId xmlns:a16="http://schemas.microsoft.com/office/drawing/2014/main" id="{067F4A04-97BC-79D8-2181-BB1B4BCFFB0E}"/>
+            </a:ext>
+          </a:extLst>
+        </p:cNvPr>
+        <p:cNvGrpSpPr/>
+        <p:nvPr/>
+      </p:nvGrpSpPr>
+      <p:grpSpPr>
+        <a:xfrm>
+          <a:off x="0" y="0"/>
+          <a:ext cx="0" cy="0"/>
+          <a:chOff x="0" y="0"/>
+          <a:chExt cx="0" cy="0"/>
+        </a:xfrm>
+      </p:grpSpPr>
+      <p:sp>
+        <p:nvSpPr>
+          <p:cNvPr id="8" name="TextBox 7">
+            <a:extLst>
+              <a:ext uri="{FF2B5EF4-FFF2-40B4-BE49-F238E27FC236}">
+                <a16:creationId xmlns:a16="http://schemas.microsoft.com/office/drawing/2014/main" id="{633C72BA-F99C-DA0E-5C3C-0F79961BAEBE}"/>
+              </a:ext>
+            </a:extLst>
+          </p:cNvPr>
+          <p:cNvSpPr txBox="1"/>
+          <p:nvPr/>
+        </p:nvSpPr>
+        <p:spPr>
+          <a:xfrm>
+            <a:off x="314958" y="935548"/>
+            <a:ext cx="548640" cy="707886"/>
+          </a:xfrm>
+          <a:prstGeom prst="rect">
+            <a:avLst/>
+          </a:prstGeom>
+          <a:noFill/>
+        </p:spPr>
+        <p:txBody>
+          <a:bodyPr wrap="square" rtlCol="0">
+            <a:spAutoFit/>
+          </a:bodyPr>
+          <a:lstStyle/>
+          <a:p>
+            <a:r>
+              <a:rPr lang="en-US" sz="4000" b="1" dirty="0"/>
+              <a:t>A</a:t>
+            </a:r>
+          </a:p>
+        </p:txBody>
+      </p:sp>
+      <p:sp>
+        <p:nvSpPr>
+          <p:cNvPr id="9" name="TextBox 8">
+            <a:extLst>
+              <a:ext uri="{FF2B5EF4-FFF2-40B4-BE49-F238E27FC236}">
+                <a16:creationId xmlns:a16="http://schemas.microsoft.com/office/drawing/2014/main" id="{853630F1-7F9B-73A7-031F-041BF671FB06}"/>
+              </a:ext>
+            </a:extLst>
+          </p:cNvPr>
+          <p:cNvSpPr txBox="1"/>
+          <p:nvPr/>
+        </p:nvSpPr>
+        <p:spPr>
+          <a:xfrm>
+            <a:off x="5811520" y="935548"/>
+            <a:ext cx="548640" cy="707886"/>
+          </a:xfrm>
+          <a:prstGeom prst="rect">
+            <a:avLst/>
+          </a:prstGeom>
+          <a:noFill/>
+        </p:spPr>
+        <p:txBody>
+          <a:bodyPr wrap="square" rtlCol="0">
+            <a:spAutoFit/>
+          </a:bodyPr>
+          <a:lstStyle/>
+          <a:p>
+            <a:r>
+              <a:rPr lang="en-US" sz="4000" b="1" dirty="0"/>
+              <a:t>B</a:t>
+            </a:r>
+          </a:p>
+        </p:txBody>
+      </p:sp>
+      <p:cxnSp>
+        <p:nvCxnSpPr>
+          <p:cNvPr id="11" name="Straight Connector 10">
+            <a:extLst>
+              <a:ext uri="{FF2B5EF4-FFF2-40B4-BE49-F238E27FC236}">
+                <a16:creationId xmlns:a16="http://schemas.microsoft.com/office/drawing/2014/main" id="{DBA88F99-3965-EE56-0F88-18C3ED49E0A1}"/>
+              </a:ext>
+            </a:extLst>
+          </p:cNvPr>
+          <p:cNvCxnSpPr/>
+          <p:nvPr/>
+        </p:nvCxnSpPr>
+        <p:spPr>
+          <a:xfrm>
+            <a:off x="5323840" y="558800"/>
+            <a:ext cx="0" cy="5655733"/>
+          </a:xfrm>
+          <a:prstGeom prst="line">
+            <a:avLst/>
+          </a:prstGeom>
+          <a:ln w="19050" cap="flat" cmpd="sng" algn="ctr">
+            <a:solidFill>
+              <a:schemeClr val="dk1"/>
+            </a:solidFill>
+            <a:prstDash val="dash"/>
+            <a:round/>
+            <a:headEnd type="none" w="med" len="med"/>
+            <a:tailEnd type="none" w="med" len="med"/>
+          </a:ln>
+        </p:spPr>
+        <p:style>
+          <a:lnRef idx="0">
+            <a:scrgbClr r="0" g="0" b="0"/>
+          </a:lnRef>
+          <a:fillRef idx="0">
+            <a:scrgbClr r="0" g="0" b="0"/>
+          </a:fillRef>
+          <a:effectRef idx="0">
+            <a:scrgbClr r="0" g="0" b="0"/>
+          </a:effectRef>
+          <a:fontRef idx="minor">
+            <a:schemeClr val="tx1"/>
+          </a:fontRef>
+        </p:style>
+      </p:cxnSp>
+      <p:pic>
+        <p:nvPicPr>
+          <p:cNvPr id="3" name="Picture 2">
+            <a:extLst>
+              <a:ext uri="{FF2B5EF4-FFF2-40B4-BE49-F238E27FC236}">
+                <a16:creationId xmlns:a16="http://schemas.microsoft.com/office/drawing/2014/main" id="{76286326-5540-00AF-4BD6-2DC225DBB57A}"/>
+              </a:ext>
+            </a:extLst>
+          </p:cNvPr>
+          <p:cNvPicPr>
+            <a:picLocks noChangeAspect="1"/>
+          </p:cNvPicPr>
+          <p:nvPr/>
+        </p:nvPicPr>
+        <p:blipFill>
+          <a:blip r:embed="rId2"/>
+          <a:stretch>
+            <a:fillRect/>
+          </a:stretch>
+        </p:blipFill>
+        <p:spPr>
+          <a:xfrm>
+            <a:off x="6800425" y="934194"/>
+            <a:ext cx="4334234" cy="5452533"/>
+          </a:xfrm>
+          <a:prstGeom prst="rect">
+            <a:avLst/>
+          </a:prstGeom>
+        </p:spPr>
+      </p:pic>
+      <p:pic>
+        <p:nvPicPr>
+          <p:cNvPr id="6" name="Picture 5">
+            <a:extLst>
+              <a:ext uri="{FF2B5EF4-FFF2-40B4-BE49-F238E27FC236}">
+                <a16:creationId xmlns:a16="http://schemas.microsoft.com/office/drawing/2014/main" id="{ED63819D-4B3F-36FD-4B41-7CAF2E94E887}"/>
+              </a:ext>
+            </a:extLst>
+          </p:cNvPr>
+          <p:cNvPicPr>
+            <a:picLocks noChangeAspect="1"/>
+          </p:cNvPicPr>
+          <p:nvPr/>
+        </p:nvPicPr>
+        <p:blipFill>
+          <a:blip r:embed="rId3"/>
+          <a:stretch>
+            <a:fillRect/>
+          </a:stretch>
+        </p:blipFill>
+        <p:spPr>
+          <a:xfrm>
+            <a:off x="869347" y="935548"/>
+            <a:ext cx="4297680" cy="5674281"/>
+          </a:xfrm>
+          <a:prstGeom prst="rect">
+            <a:avLst/>
+          </a:prstGeom>
+        </p:spPr>
+      </p:pic>
+    </p:spTree>
+    <p:extLst>
+      <p:ext uri="{BB962C8B-B14F-4D97-AF65-F5344CB8AC3E}">
+        <p14:creationId xmlns:p14="http://schemas.microsoft.com/office/powerpoint/2010/main" val="286718301"/>
+      </p:ext>
+    </p:extLst>
+  </p:cSld>
+  <p:clrMapOvr>
+    <a:masterClrMapping/>
+  </p:clrMapOvr>
+</p:sld>
+</file>
+
 <file path=ppt/theme/theme1.xml><?xml version="1.0" encoding="utf-8"?>
 <a:theme xmlns:a="http://schemas.openxmlformats.org/drawingml/2006/main" name="Office Theme">
   <a:themeElements>

</xml_diff>

<commit_message>
add more validation to normalization script
</commit_message>
<xml_diff>
--- a/Reports/Step1/figures.pptx
+++ b/Reports/Step1/figures.pptx
@@ -8,7 +8,10 @@
     <p:sldId id="256" r:id="rId2"/>
     <p:sldId id="257" r:id="rId3"/>
     <p:sldId id="258" r:id="rId4"/>
-    <p:sldId id="259" r:id="rId5"/>
+    <p:sldId id="261" r:id="rId5"/>
+    <p:sldId id="262" r:id="rId6"/>
+    <p:sldId id="260" r:id="rId7"/>
+    <p:sldId id="259" r:id="rId8"/>
   </p:sldIdLst>
   <p:sldSz cx="12192000" cy="6858000"/>
   <p:notesSz cx="6858000" cy="9144000"/>
@@ -262,7 +265,7 @@
           <a:p>
             <a:fld id="{070C54B2-02AF-4F32-9526-487D6CDB273B}" type="datetimeFigureOut">
               <a:rPr lang="en-US" smtClean="0"/>
-              <a:t>9/22/2025</a:t>
+              <a:t>10/7/2025</a:t>
             </a:fld>
             <a:endParaRPr lang="en-US"/>
           </a:p>
@@ -460,7 +463,7 @@
           <a:p>
             <a:fld id="{070C54B2-02AF-4F32-9526-487D6CDB273B}" type="datetimeFigureOut">
               <a:rPr lang="en-US" smtClean="0"/>
-              <a:t>9/22/2025</a:t>
+              <a:t>10/7/2025</a:t>
             </a:fld>
             <a:endParaRPr lang="en-US"/>
           </a:p>
@@ -668,7 +671,7 @@
           <a:p>
             <a:fld id="{070C54B2-02AF-4F32-9526-487D6CDB273B}" type="datetimeFigureOut">
               <a:rPr lang="en-US" smtClean="0"/>
-              <a:t>9/22/2025</a:t>
+              <a:t>10/7/2025</a:t>
             </a:fld>
             <a:endParaRPr lang="en-US"/>
           </a:p>
@@ -866,7 +869,7 @@
           <a:p>
             <a:fld id="{070C54B2-02AF-4F32-9526-487D6CDB273B}" type="datetimeFigureOut">
               <a:rPr lang="en-US" smtClean="0"/>
-              <a:t>9/22/2025</a:t>
+              <a:t>10/7/2025</a:t>
             </a:fld>
             <a:endParaRPr lang="en-US"/>
           </a:p>
@@ -1141,7 +1144,7 @@
           <a:p>
             <a:fld id="{070C54B2-02AF-4F32-9526-487D6CDB273B}" type="datetimeFigureOut">
               <a:rPr lang="en-US" smtClean="0"/>
-              <a:t>9/22/2025</a:t>
+              <a:t>10/7/2025</a:t>
             </a:fld>
             <a:endParaRPr lang="en-US"/>
           </a:p>
@@ -1406,7 +1409,7 @@
           <a:p>
             <a:fld id="{070C54B2-02AF-4F32-9526-487D6CDB273B}" type="datetimeFigureOut">
               <a:rPr lang="en-US" smtClean="0"/>
-              <a:t>9/22/2025</a:t>
+              <a:t>10/7/2025</a:t>
             </a:fld>
             <a:endParaRPr lang="en-US"/>
           </a:p>
@@ -1818,7 +1821,7 @@
           <a:p>
             <a:fld id="{070C54B2-02AF-4F32-9526-487D6CDB273B}" type="datetimeFigureOut">
               <a:rPr lang="en-US" smtClean="0"/>
-              <a:t>9/22/2025</a:t>
+              <a:t>10/7/2025</a:t>
             </a:fld>
             <a:endParaRPr lang="en-US"/>
           </a:p>
@@ -1959,7 +1962,7 @@
           <a:p>
             <a:fld id="{070C54B2-02AF-4F32-9526-487D6CDB273B}" type="datetimeFigureOut">
               <a:rPr lang="en-US" smtClean="0"/>
-              <a:t>9/22/2025</a:t>
+              <a:t>10/7/2025</a:t>
             </a:fld>
             <a:endParaRPr lang="en-US"/>
           </a:p>
@@ -2072,7 +2075,7 @@
           <a:p>
             <a:fld id="{070C54B2-02AF-4F32-9526-487D6CDB273B}" type="datetimeFigureOut">
               <a:rPr lang="en-US" smtClean="0"/>
-              <a:t>9/22/2025</a:t>
+              <a:t>10/7/2025</a:t>
             </a:fld>
             <a:endParaRPr lang="en-US"/>
           </a:p>
@@ -2383,7 +2386,7 @@
           <a:p>
             <a:fld id="{070C54B2-02AF-4F32-9526-487D6CDB273B}" type="datetimeFigureOut">
               <a:rPr lang="en-US" smtClean="0"/>
-              <a:t>9/22/2025</a:t>
+              <a:t>10/7/2025</a:t>
             </a:fld>
             <a:endParaRPr lang="en-US"/>
           </a:p>
@@ -2671,7 +2674,7 @@
           <a:p>
             <a:fld id="{070C54B2-02AF-4F32-9526-487D6CDB273B}" type="datetimeFigureOut">
               <a:rPr lang="en-US" smtClean="0"/>
-              <a:t>9/22/2025</a:t>
+              <a:t>10/7/2025</a:t>
             </a:fld>
             <a:endParaRPr lang="en-US"/>
           </a:p>
@@ -2912,7 +2915,7 @@
           <a:p>
             <a:fld id="{070C54B2-02AF-4F32-9526-487D6CDB273B}" type="datetimeFigureOut">
               <a:rPr lang="en-US" smtClean="0"/>
-              <a:t>9/22/2025</a:t>
+              <a:t>10/7/2025</a:t>
             </a:fld>
             <a:endParaRPr lang="en-US"/>
           </a:p>
@@ -4380,6 +4383,1784 @@
         <p:cNvPr id="1" name="">
           <a:extLst>
             <a:ext uri="{FF2B5EF4-FFF2-40B4-BE49-F238E27FC236}">
+              <a16:creationId xmlns:a16="http://schemas.microsoft.com/office/drawing/2014/main" id="{C422BCA4-01DC-B39B-4A07-3D297F6A9221}"/>
+            </a:ext>
+          </a:extLst>
+        </p:cNvPr>
+        <p:cNvGrpSpPr/>
+        <p:nvPr/>
+      </p:nvGrpSpPr>
+      <p:grpSpPr>
+        <a:xfrm>
+          <a:off x="0" y="0"/>
+          <a:ext cx="0" cy="0"/>
+          <a:chOff x="0" y="0"/>
+          <a:chExt cx="0" cy="0"/>
+        </a:xfrm>
+      </p:grpSpPr>
+      <p:sp>
+        <p:nvSpPr>
+          <p:cNvPr id="8" name="TextBox 7">
+            <a:extLst>
+              <a:ext uri="{FF2B5EF4-FFF2-40B4-BE49-F238E27FC236}">
+                <a16:creationId xmlns:a16="http://schemas.microsoft.com/office/drawing/2014/main" id="{259F6A6F-3C2B-7923-B894-7A388FDC52F7}"/>
+              </a:ext>
+            </a:extLst>
+          </p:cNvPr>
+          <p:cNvSpPr txBox="1"/>
+          <p:nvPr/>
+        </p:nvSpPr>
+        <p:spPr>
+          <a:xfrm>
+            <a:off x="2227" y="0"/>
+            <a:ext cx="548640" cy="584775"/>
+          </a:xfrm>
+          <a:prstGeom prst="rect">
+            <a:avLst/>
+          </a:prstGeom>
+          <a:noFill/>
+        </p:spPr>
+        <p:txBody>
+          <a:bodyPr wrap="square" rtlCol="0">
+            <a:spAutoFit/>
+          </a:bodyPr>
+          <a:lstStyle/>
+          <a:p>
+            <a:r>
+              <a:rPr lang="en-US" sz="3200" b="1" dirty="0"/>
+              <a:t>A</a:t>
+            </a:r>
+          </a:p>
+        </p:txBody>
+      </p:sp>
+      <p:sp>
+        <p:nvSpPr>
+          <p:cNvPr id="9" name="TextBox 8">
+            <a:extLst>
+              <a:ext uri="{FF2B5EF4-FFF2-40B4-BE49-F238E27FC236}">
+                <a16:creationId xmlns:a16="http://schemas.microsoft.com/office/drawing/2014/main" id="{A7C201CA-7562-F9AD-89FF-E5FC1629E2CB}"/>
+              </a:ext>
+            </a:extLst>
+          </p:cNvPr>
+          <p:cNvSpPr txBox="1"/>
+          <p:nvPr/>
+        </p:nvSpPr>
+        <p:spPr>
+          <a:xfrm>
+            <a:off x="27625" y="3636146"/>
+            <a:ext cx="548640" cy="584775"/>
+          </a:xfrm>
+          <a:prstGeom prst="rect">
+            <a:avLst/>
+          </a:prstGeom>
+          <a:noFill/>
+        </p:spPr>
+        <p:txBody>
+          <a:bodyPr wrap="square" rtlCol="0">
+            <a:spAutoFit/>
+          </a:bodyPr>
+          <a:lstStyle/>
+          <a:p>
+            <a:r>
+              <a:rPr lang="en-US" sz="3200" b="1" dirty="0"/>
+              <a:t>D</a:t>
+            </a:r>
+          </a:p>
+        </p:txBody>
+      </p:sp>
+      <p:cxnSp>
+        <p:nvCxnSpPr>
+          <p:cNvPr id="11" name="Straight Connector 10">
+            <a:extLst>
+              <a:ext uri="{FF2B5EF4-FFF2-40B4-BE49-F238E27FC236}">
+                <a16:creationId xmlns:a16="http://schemas.microsoft.com/office/drawing/2014/main" id="{2898CDD7-8086-B8BC-63E1-853D6938D9E7}"/>
+              </a:ext>
+            </a:extLst>
+          </p:cNvPr>
+          <p:cNvCxnSpPr>
+            <a:cxnSpLocks/>
+          </p:cNvCxnSpPr>
+          <p:nvPr/>
+        </p:nvCxnSpPr>
+        <p:spPr>
+          <a:xfrm>
+            <a:off x="0" y="3532093"/>
+            <a:ext cx="12192000" cy="24650"/>
+          </a:xfrm>
+          <a:prstGeom prst="line">
+            <a:avLst/>
+          </a:prstGeom>
+          <a:ln w="19050" cap="flat" cmpd="sng" algn="ctr">
+            <a:solidFill>
+              <a:schemeClr val="dk1"/>
+            </a:solidFill>
+            <a:prstDash val="dash"/>
+            <a:round/>
+            <a:headEnd type="none" w="med" len="med"/>
+            <a:tailEnd type="none" w="med" len="med"/>
+          </a:ln>
+        </p:spPr>
+        <p:style>
+          <a:lnRef idx="0">
+            <a:scrgbClr r="0" g="0" b="0"/>
+          </a:lnRef>
+          <a:fillRef idx="0">
+            <a:scrgbClr r="0" g="0" b="0"/>
+          </a:fillRef>
+          <a:effectRef idx="0">
+            <a:scrgbClr r="0" g="0" b="0"/>
+          </a:effectRef>
+          <a:fontRef idx="minor">
+            <a:schemeClr val="tx1"/>
+          </a:fontRef>
+        </p:style>
+      </p:cxnSp>
+      <p:sp>
+        <p:nvSpPr>
+          <p:cNvPr id="21" name="TextBox 20">
+            <a:extLst>
+              <a:ext uri="{FF2B5EF4-FFF2-40B4-BE49-F238E27FC236}">
+                <a16:creationId xmlns:a16="http://schemas.microsoft.com/office/drawing/2014/main" id="{CFF4C8B4-17A8-D132-11D6-90C3CCB756EB}"/>
+              </a:ext>
+            </a:extLst>
+          </p:cNvPr>
+          <p:cNvSpPr txBox="1"/>
+          <p:nvPr/>
+        </p:nvSpPr>
+        <p:spPr>
+          <a:xfrm>
+            <a:off x="4027495" y="3593811"/>
+            <a:ext cx="548640" cy="584775"/>
+          </a:xfrm>
+          <a:prstGeom prst="rect">
+            <a:avLst/>
+          </a:prstGeom>
+          <a:noFill/>
+        </p:spPr>
+        <p:txBody>
+          <a:bodyPr wrap="square" rtlCol="0">
+            <a:spAutoFit/>
+          </a:bodyPr>
+          <a:lstStyle/>
+          <a:p>
+            <a:r>
+              <a:rPr lang="en-US" sz="3200" b="1" dirty="0"/>
+              <a:t>E</a:t>
+            </a:r>
+          </a:p>
+        </p:txBody>
+      </p:sp>
+      <p:sp>
+        <p:nvSpPr>
+          <p:cNvPr id="22" name="TextBox 21">
+            <a:extLst>
+              <a:ext uri="{FF2B5EF4-FFF2-40B4-BE49-F238E27FC236}">
+                <a16:creationId xmlns:a16="http://schemas.microsoft.com/office/drawing/2014/main" id="{9EF0602D-85A8-5A1C-22CE-A2DEB81EAA38}"/>
+              </a:ext>
+            </a:extLst>
+          </p:cNvPr>
+          <p:cNvSpPr txBox="1"/>
+          <p:nvPr/>
+        </p:nvSpPr>
+        <p:spPr>
+          <a:xfrm>
+            <a:off x="8362429" y="3636146"/>
+            <a:ext cx="548640" cy="584775"/>
+          </a:xfrm>
+          <a:prstGeom prst="rect">
+            <a:avLst/>
+          </a:prstGeom>
+          <a:noFill/>
+        </p:spPr>
+        <p:txBody>
+          <a:bodyPr wrap="square" rtlCol="0">
+            <a:spAutoFit/>
+          </a:bodyPr>
+          <a:lstStyle/>
+          <a:p>
+            <a:r>
+              <a:rPr lang="en-US" sz="3200" b="1" dirty="0"/>
+              <a:t>F</a:t>
+            </a:r>
+          </a:p>
+        </p:txBody>
+      </p:sp>
+      <p:cxnSp>
+        <p:nvCxnSpPr>
+          <p:cNvPr id="26" name="Straight Connector 25">
+            <a:extLst>
+              <a:ext uri="{FF2B5EF4-FFF2-40B4-BE49-F238E27FC236}">
+                <a16:creationId xmlns:a16="http://schemas.microsoft.com/office/drawing/2014/main" id="{26FD1F00-26ED-FD9A-95AE-E365E45EDD3D}"/>
+              </a:ext>
+            </a:extLst>
+          </p:cNvPr>
+          <p:cNvCxnSpPr>
+            <a:cxnSpLocks/>
+          </p:cNvCxnSpPr>
+          <p:nvPr/>
+        </p:nvCxnSpPr>
+        <p:spPr>
+          <a:xfrm>
+            <a:off x="4019023" y="-1"/>
+            <a:ext cx="0" cy="6858001"/>
+          </a:xfrm>
+          <a:prstGeom prst="line">
+            <a:avLst/>
+          </a:prstGeom>
+          <a:ln w="19050" cap="flat" cmpd="sng" algn="ctr">
+            <a:solidFill>
+              <a:schemeClr val="dk1"/>
+            </a:solidFill>
+            <a:prstDash val="dash"/>
+            <a:round/>
+            <a:headEnd type="none" w="med" len="med"/>
+            <a:tailEnd type="none" w="med" len="med"/>
+          </a:ln>
+        </p:spPr>
+        <p:style>
+          <a:lnRef idx="0">
+            <a:scrgbClr r="0" g="0" b="0"/>
+          </a:lnRef>
+          <a:fillRef idx="0">
+            <a:scrgbClr r="0" g="0" b="0"/>
+          </a:fillRef>
+          <a:effectRef idx="0">
+            <a:scrgbClr r="0" g="0" b="0"/>
+          </a:effectRef>
+          <a:fontRef idx="minor">
+            <a:schemeClr val="tx1"/>
+          </a:fontRef>
+        </p:style>
+      </p:cxnSp>
+      <p:cxnSp>
+        <p:nvCxnSpPr>
+          <p:cNvPr id="27" name="Straight Connector 26">
+            <a:extLst>
+              <a:ext uri="{FF2B5EF4-FFF2-40B4-BE49-F238E27FC236}">
+                <a16:creationId xmlns:a16="http://schemas.microsoft.com/office/drawing/2014/main" id="{F1207647-D634-7B7F-3ECD-43BB7891AC18}"/>
+              </a:ext>
+            </a:extLst>
+          </p:cNvPr>
+          <p:cNvCxnSpPr/>
+          <p:nvPr/>
+        </p:nvCxnSpPr>
+        <p:spPr>
+          <a:xfrm>
+            <a:off x="8193106" y="-24669"/>
+            <a:ext cx="0" cy="6976872"/>
+          </a:xfrm>
+          <a:prstGeom prst="line">
+            <a:avLst/>
+          </a:prstGeom>
+          <a:ln w="19050" cap="flat" cmpd="sng" algn="ctr">
+            <a:solidFill>
+              <a:schemeClr val="dk1"/>
+            </a:solidFill>
+            <a:prstDash val="dash"/>
+            <a:round/>
+            <a:headEnd type="none" w="med" len="med"/>
+            <a:tailEnd type="none" w="med" len="med"/>
+          </a:ln>
+        </p:spPr>
+        <p:style>
+          <a:lnRef idx="0">
+            <a:scrgbClr r="0" g="0" b="0"/>
+          </a:lnRef>
+          <a:fillRef idx="0">
+            <a:scrgbClr r="0" g="0" b="0"/>
+          </a:fillRef>
+          <a:effectRef idx="0">
+            <a:scrgbClr r="0" g="0" b="0"/>
+          </a:effectRef>
+          <a:fontRef idx="minor">
+            <a:schemeClr val="tx1"/>
+          </a:fontRef>
+        </p:style>
+      </p:cxnSp>
+      <p:pic>
+        <p:nvPicPr>
+          <p:cNvPr id="6" name="Picture 5">
+            <a:extLst>
+              <a:ext uri="{FF2B5EF4-FFF2-40B4-BE49-F238E27FC236}">
+                <a16:creationId xmlns:a16="http://schemas.microsoft.com/office/drawing/2014/main" id="{44E52E5B-EC63-DCD7-56A4-4D0CFDE266E4}"/>
+              </a:ext>
+            </a:extLst>
+          </p:cNvPr>
+          <p:cNvPicPr>
+            <a:picLocks noChangeAspect="1"/>
+          </p:cNvPicPr>
+          <p:nvPr/>
+        </p:nvPicPr>
+        <p:blipFill>
+          <a:blip r:embed="rId2"/>
+          <a:srcRect r="2438"/>
+          <a:stretch>
+            <a:fillRect/>
+          </a:stretch>
+        </p:blipFill>
+        <p:spPr>
+          <a:xfrm>
+            <a:off x="8275301" y="4219419"/>
+            <a:ext cx="3861862" cy="2299912"/>
+          </a:xfrm>
+          <a:prstGeom prst="rect">
+            <a:avLst/>
+          </a:prstGeom>
+        </p:spPr>
+      </p:pic>
+      <p:pic>
+        <p:nvPicPr>
+          <p:cNvPr id="10" name="Picture 9">
+            <a:extLst>
+              <a:ext uri="{FF2B5EF4-FFF2-40B4-BE49-F238E27FC236}">
+                <a16:creationId xmlns:a16="http://schemas.microsoft.com/office/drawing/2014/main" id="{01755B18-9B45-C21A-3D70-74E4323002FF}"/>
+              </a:ext>
+            </a:extLst>
+          </p:cNvPr>
+          <p:cNvPicPr>
+            <a:picLocks noChangeAspect="1"/>
+          </p:cNvPicPr>
+          <p:nvPr/>
+        </p:nvPicPr>
+        <p:blipFill>
+          <a:blip r:embed="rId3"/>
+          <a:stretch>
+            <a:fillRect/>
+          </a:stretch>
+        </p:blipFill>
+        <p:spPr>
+          <a:xfrm>
+            <a:off x="45907" y="606951"/>
+            <a:ext cx="3887664" cy="2296533"/>
+          </a:xfrm>
+          <a:prstGeom prst="rect">
+            <a:avLst/>
+          </a:prstGeom>
+        </p:spPr>
+      </p:pic>
+      <p:pic>
+        <p:nvPicPr>
+          <p:cNvPr id="14" name="Picture 13">
+            <a:extLst>
+              <a:ext uri="{FF2B5EF4-FFF2-40B4-BE49-F238E27FC236}">
+                <a16:creationId xmlns:a16="http://schemas.microsoft.com/office/drawing/2014/main" id="{EFC0421A-031B-8CA3-CD9B-73421A7C7610}"/>
+              </a:ext>
+            </a:extLst>
+          </p:cNvPr>
+          <p:cNvPicPr>
+            <a:picLocks noChangeAspect="1"/>
+          </p:cNvPicPr>
+          <p:nvPr/>
+        </p:nvPicPr>
+        <p:blipFill>
+          <a:blip r:embed="rId4"/>
+          <a:stretch>
+            <a:fillRect/>
+          </a:stretch>
+        </p:blipFill>
+        <p:spPr>
+          <a:xfrm>
+            <a:off x="4049245" y="504766"/>
+            <a:ext cx="4065863" cy="2461797"/>
+          </a:xfrm>
+          <a:prstGeom prst="rect">
+            <a:avLst/>
+          </a:prstGeom>
+        </p:spPr>
+      </p:pic>
+      <p:pic>
+        <p:nvPicPr>
+          <p:cNvPr id="17" name="Picture 16">
+            <a:extLst>
+              <a:ext uri="{FF2B5EF4-FFF2-40B4-BE49-F238E27FC236}">
+                <a16:creationId xmlns:a16="http://schemas.microsoft.com/office/drawing/2014/main" id="{C9BB89A6-8F47-23AA-E89C-B19C602F842A}"/>
+              </a:ext>
+            </a:extLst>
+          </p:cNvPr>
+          <p:cNvPicPr>
+            <a:picLocks noChangeAspect="1"/>
+          </p:cNvPicPr>
+          <p:nvPr/>
+        </p:nvPicPr>
+        <p:blipFill>
+          <a:blip r:embed="rId5"/>
+          <a:srcRect t="4263" r="1433"/>
+          <a:stretch>
+            <a:fillRect/>
+          </a:stretch>
+        </p:blipFill>
+        <p:spPr>
+          <a:xfrm>
+            <a:off x="8311659" y="573083"/>
+            <a:ext cx="3777925" cy="2325163"/>
+          </a:xfrm>
+          <a:prstGeom prst="rect">
+            <a:avLst/>
+          </a:prstGeom>
+        </p:spPr>
+      </p:pic>
+      <p:sp>
+        <p:nvSpPr>
+          <p:cNvPr id="19" name="TextBox 18">
+            <a:extLst>
+              <a:ext uri="{FF2B5EF4-FFF2-40B4-BE49-F238E27FC236}">
+                <a16:creationId xmlns:a16="http://schemas.microsoft.com/office/drawing/2014/main" id="{8FCE2910-F271-0CF1-B1E2-F7AD4A40FD8F}"/>
+              </a:ext>
+            </a:extLst>
+          </p:cNvPr>
+          <p:cNvSpPr txBox="1"/>
+          <p:nvPr/>
+        </p:nvSpPr>
+        <p:spPr>
+          <a:xfrm>
+            <a:off x="4072462" y="-1"/>
+            <a:ext cx="548640" cy="584775"/>
+          </a:xfrm>
+          <a:prstGeom prst="rect">
+            <a:avLst/>
+          </a:prstGeom>
+          <a:noFill/>
+        </p:spPr>
+        <p:txBody>
+          <a:bodyPr wrap="square" rtlCol="0">
+            <a:spAutoFit/>
+          </a:bodyPr>
+          <a:lstStyle/>
+          <a:p>
+            <a:r>
+              <a:rPr lang="en-US" sz="3200" b="1" dirty="0"/>
+              <a:t>B</a:t>
+            </a:r>
+          </a:p>
+        </p:txBody>
+      </p:sp>
+      <p:pic>
+        <p:nvPicPr>
+          <p:cNvPr id="24" name="Picture 23">
+            <a:extLst>
+              <a:ext uri="{FF2B5EF4-FFF2-40B4-BE49-F238E27FC236}">
+                <a16:creationId xmlns:a16="http://schemas.microsoft.com/office/drawing/2014/main" id="{1F5218EC-7704-88B7-1E23-311A21245132}"/>
+              </a:ext>
+            </a:extLst>
+          </p:cNvPr>
+          <p:cNvPicPr>
+            <a:picLocks noChangeAspect="1"/>
+          </p:cNvPicPr>
+          <p:nvPr/>
+        </p:nvPicPr>
+        <p:blipFill>
+          <a:blip r:embed="rId6"/>
+          <a:srcRect t="3415" r="4228"/>
+          <a:stretch>
+            <a:fillRect/>
+          </a:stretch>
+        </p:blipFill>
+        <p:spPr>
+          <a:xfrm>
+            <a:off x="50766" y="4183981"/>
+            <a:ext cx="3927712" cy="2521616"/>
+          </a:xfrm>
+          <a:prstGeom prst="rect">
+            <a:avLst/>
+          </a:prstGeom>
+        </p:spPr>
+      </p:pic>
+      <p:sp>
+        <p:nvSpPr>
+          <p:cNvPr id="28" name="TextBox 27">
+            <a:extLst>
+              <a:ext uri="{FF2B5EF4-FFF2-40B4-BE49-F238E27FC236}">
+                <a16:creationId xmlns:a16="http://schemas.microsoft.com/office/drawing/2014/main" id="{48A7A27E-056C-467C-C206-0F0EC639309F}"/>
+              </a:ext>
+            </a:extLst>
+          </p:cNvPr>
+          <p:cNvSpPr txBox="1"/>
+          <p:nvPr/>
+        </p:nvSpPr>
+        <p:spPr>
+          <a:xfrm>
+            <a:off x="8246539" y="16932"/>
+            <a:ext cx="548640" cy="584775"/>
+          </a:xfrm>
+          <a:prstGeom prst="rect">
+            <a:avLst/>
+          </a:prstGeom>
+          <a:noFill/>
+        </p:spPr>
+        <p:txBody>
+          <a:bodyPr wrap="square" rtlCol="0">
+            <a:spAutoFit/>
+          </a:bodyPr>
+          <a:lstStyle/>
+          <a:p>
+            <a:r>
+              <a:rPr lang="en-US" sz="3200" b="1" dirty="0"/>
+              <a:t>C</a:t>
+            </a:r>
+          </a:p>
+        </p:txBody>
+      </p:sp>
+      <p:pic>
+        <p:nvPicPr>
+          <p:cNvPr id="30" name="Picture 29">
+            <a:extLst>
+              <a:ext uri="{FF2B5EF4-FFF2-40B4-BE49-F238E27FC236}">
+                <a16:creationId xmlns:a16="http://schemas.microsoft.com/office/drawing/2014/main" id="{90F007F5-1ADD-704C-C1D4-37BDE0BC0C09}"/>
+              </a:ext>
+            </a:extLst>
+          </p:cNvPr>
+          <p:cNvPicPr>
+            <a:picLocks noChangeAspect="1"/>
+          </p:cNvPicPr>
+          <p:nvPr/>
+        </p:nvPicPr>
+        <p:blipFill>
+          <a:blip r:embed="rId7"/>
+          <a:stretch>
+            <a:fillRect/>
+          </a:stretch>
+        </p:blipFill>
+        <p:spPr>
+          <a:xfrm>
+            <a:off x="4085337" y="4160956"/>
+            <a:ext cx="4045306" cy="2358375"/>
+          </a:xfrm>
+          <a:prstGeom prst="rect">
+            <a:avLst/>
+          </a:prstGeom>
+        </p:spPr>
+      </p:pic>
+    </p:spTree>
+    <p:extLst>
+      <p:ext uri="{BB962C8B-B14F-4D97-AF65-F5344CB8AC3E}">
+        <p14:creationId xmlns:p14="http://schemas.microsoft.com/office/powerpoint/2010/main" val="3424945216"/>
+      </p:ext>
+    </p:extLst>
+  </p:cSld>
+  <p:clrMapOvr>
+    <a:masterClrMapping/>
+  </p:clrMapOvr>
+</p:sld>
+</file>
+
+<file path=ppt/slides/slide5.xml><?xml version="1.0" encoding="utf-8"?>
+<p:sld xmlns:a="http://schemas.openxmlformats.org/drawingml/2006/main" xmlns:r="http://schemas.openxmlformats.org/officeDocument/2006/relationships" xmlns:p="http://schemas.openxmlformats.org/presentationml/2006/main">
+  <p:cSld>
+    <p:bg>
+      <p:bgPr>
+        <a:solidFill>
+          <a:schemeClr val="bg1"/>
+        </a:solidFill>
+        <a:effectLst/>
+      </p:bgPr>
+    </p:bg>
+    <p:spTree>
+      <p:nvGrpSpPr>
+        <p:cNvPr id="1" name="">
+          <a:extLst>
+            <a:ext uri="{FF2B5EF4-FFF2-40B4-BE49-F238E27FC236}">
+              <a16:creationId xmlns:a16="http://schemas.microsoft.com/office/drawing/2014/main" id="{440DBB1C-7EA2-D251-BF63-3329A66F7B51}"/>
+            </a:ext>
+          </a:extLst>
+        </p:cNvPr>
+        <p:cNvGrpSpPr/>
+        <p:nvPr/>
+      </p:nvGrpSpPr>
+      <p:grpSpPr>
+        <a:xfrm>
+          <a:off x="0" y="0"/>
+          <a:ext cx="0" cy="0"/>
+          <a:chOff x="0" y="0"/>
+          <a:chExt cx="0" cy="0"/>
+        </a:xfrm>
+      </p:grpSpPr>
+      <p:sp>
+        <p:nvSpPr>
+          <p:cNvPr id="8" name="TextBox 7">
+            <a:extLst>
+              <a:ext uri="{FF2B5EF4-FFF2-40B4-BE49-F238E27FC236}">
+                <a16:creationId xmlns:a16="http://schemas.microsoft.com/office/drawing/2014/main" id="{92C876EA-E28C-562E-5473-96711DB0EBC3}"/>
+              </a:ext>
+            </a:extLst>
+          </p:cNvPr>
+          <p:cNvSpPr txBox="1"/>
+          <p:nvPr/>
+        </p:nvSpPr>
+        <p:spPr>
+          <a:xfrm>
+            <a:off x="2227" y="0"/>
+            <a:ext cx="548640" cy="584775"/>
+          </a:xfrm>
+          <a:prstGeom prst="rect">
+            <a:avLst/>
+          </a:prstGeom>
+          <a:noFill/>
+        </p:spPr>
+        <p:txBody>
+          <a:bodyPr wrap="square" rtlCol="0">
+            <a:spAutoFit/>
+          </a:bodyPr>
+          <a:lstStyle/>
+          <a:p>
+            <a:r>
+              <a:rPr lang="en-US" sz="3200" b="1" dirty="0"/>
+              <a:t>A</a:t>
+            </a:r>
+          </a:p>
+        </p:txBody>
+      </p:sp>
+      <p:sp>
+        <p:nvSpPr>
+          <p:cNvPr id="9" name="TextBox 8">
+            <a:extLst>
+              <a:ext uri="{FF2B5EF4-FFF2-40B4-BE49-F238E27FC236}">
+                <a16:creationId xmlns:a16="http://schemas.microsoft.com/office/drawing/2014/main" id="{E26D7EAA-2347-FEFF-BD71-4AB980A08CC9}"/>
+              </a:ext>
+            </a:extLst>
+          </p:cNvPr>
+          <p:cNvSpPr txBox="1"/>
+          <p:nvPr/>
+        </p:nvSpPr>
+        <p:spPr>
+          <a:xfrm>
+            <a:off x="27625" y="3636146"/>
+            <a:ext cx="548640" cy="584775"/>
+          </a:xfrm>
+          <a:prstGeom prst="rect">
+            <a:avLst/>
+          </a:prstGeom>
+          <a:noFill/>
+        </p:spPr>
+        <p:txBody>
+          <a:bodyPr wrap="square" rtlCol="0">
+            <a:spAutoFit/>
+          </a:bodyPr>
+          <a:lstStyle/>
+          <a:p>
+            <a:r>
+              <a:rPr lang="en-US" sz="3200" b="1" dirty="0"/>
+              <a:t>D</a:t>
+            </a:r>
+          </a:p>
+        </p:txBody>
+      </p:sp>
+      <p:cxnSp>
+        <p:nvCxnSpPr>
+          <p:cNvPr id="11" name="Straight Connector 10">
+            <a:extLst>
+              <a:ext uri="{FF2B5EF4-FFF2-40B4-BE49-F238E27FC236}">
+                <a16:creationId xmlns:a16="http://schemas.microsoft.com/office/drawing/2014/main" id="{FC8C4F49-F5C4-B485-4804-8AAF72D799A7}"/>
+              </a:ext>
+            </a:extLst>
+          </p:cNvPr>
+          <p:cNvCxnSpPr>
+            <a:cxnSpLocks/>
+          </p:cNvCxnSpPr>
+          <p:nvPr/>
+        </p:nvCxnSpPr>
+        <p:spPr>
+          <a:xfrm>
+            <a:off x="0" y="3532093"/>
+            <a:ext cx="12192000" cy="24650"/>
+          </a:xfrm>
+          <a:prstGeom prst="line">
+            <a:avLst/>
+          </a:prstGeom>
+          <a:ln w="19050" cap="flat" cmpd="sng" algn="ctr">
+            <a:solidFill>
+              <a:schemeClr val="dk1"/>
+            </a:solidFill>
+            <a:prstDash val="dash"/>
+            <a:round/>
+            <a:headEnd type="none" w="med" len="med"/>
+            <a:tailEnd type="none" w="med" len="med"/>
+          </a:ln>
+        </p:spPr>
+        <p:style>
+          <a:lnRef idx="0">
+            <a:scrgbClr r="0" g="0" b="0"/>
+          </a:lnRef>
+          <a:fillRef idx="0">
+            <a:scrgbClr r="0" g="0" b="0"/>
+          </a:fillRef>
+          <a:effectRef idx="0">
+            <a:scrgbClr r="0" g="0" b="0"/>
+          </a:effectRef>
+          <a:fontRef idx="minor">
+            <a:schemeClr val="tx1"/>
+          </a:fontRef>
+        </p:style>
+      </p:cxnSp>
+      <p:sp>
+        <p:nvSpPr>
+          <p:cNvPr id="21" name="TextBox 20">
+            <a:extLst>
+              <a:ext uri="{FF2B5EF4-FFF2-40B4-BE49-F238E27FC236}">
+                <a16:creationId xmlns:a16="http://schemas.microsoft.com/office/drawing/2014/main" id="{C77DD8FA-A0DC-85AC-26F4-6522C91EE1E0}"/>
+              </a:ext>
+            </a:extLst>
+          </p:cNvPr>
+          <p:cNvSpPr txBox="1"/>
+          <p:nvPr/>
+        </p:nvSpPr>
+        <p:spPr>
+          <a:xfrm>
+            <a:off x="4027495" y="3593811"/>
+            <a:ext cx="548640" cy="584775"/>
+          </a:xfrm>
+          <a:prstGeom prst="rect">
+            <a:avLst/>
+          </a:prstGeom>
+          <a:noFill/>
+        </p:spPr>
+        <p:txBody>
+          <a:bodyPr wrap="square" rtlCol="0">
+            <a:spAutoFit/>
+          </a:bodyPr>
+          <a:lstStyle/>
+          <a:p>
+            <a:r>
+              <a:rPr lang="en-US" sz="3200" b="1" dirty="0"/>
+              <a:t>E</a:t>
+            </a:r>
+          </a:p>
+        </p:txBody>
+      </p:sp>
+      <p:sp>
+        <p:nvSpPr>
+          <p:cNvPr id="22" name="TextBox 21">
+            <a:extLst>
+              <a:ext uri="{FF2B5EF4-FFF2-40B4-BE49-F238E27FC236}">
+                <a16:creationId xmlns:a16="http://schemas.microsoft.com/office/drawing/2014/main" id="{5066A111-0271-A403-968E-F127E69B427E}"/>
+              </a:ext>
+            </a:extLst>
+          </p:cNvPr>
+          <p:cNvSpPr txBox="1"/>
+          <p:nvPr/>
+        </p:nvSpPr>
+        <p:spPr>
+          <a:xfrm>
+            <a:off x="8362429" y="3636146"/>
+            <a:ext cx="548640" cy="584775"/>
+          </a:xfrm>
+          <a:prstGeom prst="rect">
+            <a:avLst/>
+          </a:prstGeom>
+          <a:noFill/>
+        </p:spPr>
+        <p:txBody>
+          <a:bodyPr wrap="square" rtlCol="0">
+            <a:spAutoFit/>
+          </a:bodyPr>
+          <a:lstStyle/>
+          <a:p>
+            <a:r>
+              <a:rPr lang="en-US" sz="3200" b="1" dirty="0"/>
+              <a:t>F</a:t>
+            </a:r>
+          </a:p>
+        </p:txBody>
+      </p:sp>
+      <p:cxnSp>
+        <p:nvCxnSpPr>
+          <p:cNvPr id="26" name="Straight Connector 25">
+            <a:extLst>
+              <a:ext uri="{FF2B5EF4-FFF2-40B4-BE49-F238E27FC236}">
+                <a16:creationId xmlns:a16="http://schemas.microsoft.com/office/drawing/2014/main" id="{2FE97797-4E3F-FCA9-1AC5-54E87AC312B0}"/>
+              </a:ext>
+            </a:extLst>
+          </p:cNvPr>
+          <p:cNvCxnSpPr>
+            <a:cxnSpLocks/>
+          </p:cNvCxnSpPr>
+          <p:nvPr/>
+        </p:nvCxnSpPr>
+        <p:spPr>
+          <a:xfrm>
+            <a:off x="4019023" y="-1"/>
+            <a:ext cx="0" cy="6858001"/>
+          </a:xfrm>
+          <a:prstGeom prst="line">
+            <a:avLst/>
+          </a:prstGeom>
+          <a:ln w="19050" cap="flat" cmpd="sng" algn="ctr">
+            <a:solidFill>
+              <a:schemeClr val="dk1"/>
+            </a:solidFill>
+            <a:prstDash val="dash"/>
+            <a:round/>
+            <a:headEnd type="none" w="med" len="med"/>
+            <a:tailEnd type="none" w="med" len="med"/>
+          </a:ln>
+        </p:spPr>
+        <p:style>
+          <a:lnRef idx="0">
+            <a:scrgbClr r="0" g="0" b="0"/>
+          </a:lnRef>
+          <a:fillRef idx="0">
+            <a:scrgbClr r="0" g="0" b="0"/>
+          </a:fillRef>
+          <a:effectRef idx="0">
+            <a:scrgbClr r="0" g="0" b="0"/>
+          </a:effectRef>
+          <a:fontRef idx="minor">
+            <a:schemeClr val="tx1"/>
+          </a:fontRef>
+        </p:style>
+      </p:cxnSp>
+      <p:cxnSp>
+        <p:nvCxnSpPr>
+          <p:cNvPr id="27" name="Straight Connector 26">
+            <a:extLst>
+              <a:ext uri="{FF2B5EF4-FFF2-40B4-BE49-F238E27FC236}">
+                <a16:creationId xmlns:a16="http://schemas.microsoft.com/office/drawing/2014/main" id="{972AC3AE-1005-6E30-F23C-460BBC816E44}"/>
+              </a:ext>
+            </a:extLst>
+          </p:cNvPr>
+          <p:cNvCxnSpPr/>
+          <p:nvPr/>
+        </p:nvCxnSpPr>
+        <p:spPr>
+          <a:xfrm>
+            <a:off x="8193106" y="-24669"/>
+            <a:ext cx="0" cy="6976872"/>
+          </a:xfrm>
+          <a:prstGeom prst="line">
+            <a:avLst/>
+          </a:prstGeom>
+          <a:ln w="19050" cap="flat" cmpd="sng" algn="ctr">
+            <a:solidFill>
+              <a:schemeClr val="dk1"/>
+            </a:solidFill>
+            <a:prstDash val="dash"/>
+            <a:round/>
+            <a:headEnd type="none" w="med" len="med"/>
+            <a:tailEnd type="none" w="med" len="med"/>
+          </a:ln>
+        </p:spPr>
+        <p:style>
+          <a:lnRef idx="0">
+            <a:scrgbClr r="0" g="0" b="0"/>
+          </a:lnRef>
+          <a:fillRef idx="0">
+            <a:scrgbClr r="0" g="0" b="0"/>
+          </a:fillRef>
+          <a:effectRef idx="0">
+            <a:scrgbClr r="0" g="0" b="0"/>
+          </a:effectRef>
+          <a:fontRef idx="minor">
+            <a:schemeClr val="tx1"/>
+          </a:fontRef>
+        </p:style>
+      </p:cxnSp>
+      <p:sp>
+        <p:nvSpPr>
+          <p:cNvPr id="19" name="TextBox 18">
+            <a:extLst>
+              <a:ext uri="{FF2B5EF4-FFF2-40B4-BE49-F238E27FC236}">
+                <a16:creationId xmlns:a16="http://schemas.microsoft.com/office/drawing/2014/main" id="{51293707-5BF7-4298-40E8-A6040B75E610}"/>
+              </a:ext>
+            </a:extLst>
+          </p:cNvPr>
+          <p:cNvSpPr txBox="1"/>
+          <p:nvPr/>
+        </p:nvSpPr>
+        <p:spPr>
+          <a:xfrm>
+            <a:off x="4072462" y="-1"/>
+            <a:ext cx="548640" cy="584775"/>
+          </a:xfrm>
+          <a:prstGeom prst="rect">
+            <a:avLst/>
+          </a:prstGeom>
+          <a:noFill/>
+        </p:spPr>
+        <p:txBody>
+          <a:bodyPr wrap="square" rtlCol="0">
+            <a:spAutoFit/>
+          </a:bodyPr>
+          <a:lstStyle/>
+          <a:p>
+            <a:r>
+              <a:rPr lang="en-US" sz="3200" b="1" dirty="0"/>
+              <a:t>B</a:t>
+            </a:r>
+          </a:p>
+        </p:txBody>
+      </p:sp>
+      <p:sp>
+        <p:nvSpPr>
+          <p:cNvPr id="28" name="TextBox 27">
+            <a:extLst>
+              <a:ext uri="{FF2B5EF4-FFF2-40B4-BE49-F238E27FC236}">
+                <a16:creationId xmlns:a16="http://schemas.microsoft.com/office/drawing/2014/main" id="{BEE21828-3164-98DE-8854-4E7FA9620757}"/>
+              </a:ext>
+            </a:extLst>
+          </p:cNvPr>
+          <p:cNvSpPr txBox="1"/>
+          <p:nvPr/>
+        </p:nvSpPr>
+        <p:spPr>
+          <a:xfrm>
+            <a:off x="8246539" y="16932"/>
+            <a:ext cx="548640" cy="584775"/>
+          </a:xfrm>
+          <a:prstGeom prst="rect">
+            <a:avLst/>
+          </a:prstGeom>
+          <a:noFill/>
+        </p:spPr>
+        <p:txBody>
+          <a:bodyPr wrap="square" rtlCol="0">
+            <a:spAutoFit/>
+          </a:bodyPr>
+          <a:lstStyle/>
+          <a:p>
+            <a:r>
+              <a:rPr lang="en-US" sz="3200" b="1" dirty="0"/>
+              <a:t>C</a:t>
+            </a:r>
+          </a:p>
+        </p:txBody>
+      </p:sp>
+      <p:pic>
+        <p:nvPicPr>
+          <p:cNvPr id="3" name="Picture 2">
+            <a:extLst>
+              <a:ext uri="{FF2B5EF4-FFF2-40B4-BE49-F238E27FC236}">
+                <a16:creationId xmlns:a16="http://schemas.microsoft.com/office/drawing/2014/main" id="{42A7A6FF-3F68-369F-4DE8-A0671C91400D}"/>
+              </a:ext>
+            </a:extLst>
+          </p:cNvPr>
+          <p:cNvPicPr>
+            <a:picLocks noChangeAspect="1"/>
+          </p:cNvPicPr>
+          <p:nvPr/>
+        </p:nvPicPr>
+        <p:blipFill>
+          <a:blip r:embed="rId2"/>
+          <a:stretch>
+            <a:fillRect/>
+          </a:stretch>
+        </p:blipFill>
+        <p:spPr>
+          <a:xfrm>
+            <a:off x="28597" y="611199"/>
+            <a:ext cx="3945452" cy="2299726"/>
+          </a:xfrm>
+          <a:prstGeom prst="rect">
+            <a:avLst/>
+          </a:prstGeom>
+        </p:spPr>
+      </p:pic>
+      <p:pic>
+        <p:nvPicPr>
+          <p:cNvPr id="5" name="Picture 4">
+            <a:extLst>
+              <a:ext uri="{FF2B5EF4-FFF2-40B4-BE49-F238E27FC236}">
+                <a16:creationId xmlns:a16="http://schemas.microsoft.com/office/drawing/2014/main" id="{A6FE7E6E-3625-97BF-C72A-CAADB2A70ABD}"/>
+              </a:ext>
+            </a:extLst>
+          </p:cNvPr>
+          <p:cNvPicPr>
+            <a:picLocks noChangeAspect="1"/>
+          </p:cNvPicPr>
+          <p:nvPr/>
+        </p:nvPicPr>
+        <p:blipFill>
+          <a:blip r:embed="rId3"/>
+          <a:stretch>
+            <a:fillRect/>
+          </a:stretch>
+        </p:blipFill>
+        <p:spPr>
+          <a:xfrm>
+            <a:off x="4080928" y="529401"/>
+            <a:ext cx="4026903" cy="2463323"/>
+          </a:xfrm>
+          <a:prstGeom prst="rect">
+            <a:avLst/>
+          </a:prstGeom>
+        </p:spPr>
+      </p:pic>
+      <p:pic>
+        <p:nvPicPr>
+          <p:cNvPr id="12" name="Picture 11">
+            <a:extLst>
+              <a:ext uri="{FF2B5EF4-FFF2-40B4-BE49-F238E27FC236}">
+                <a16:creationId xmlns:a16="http://schemas.microsoft.com/office/drawing/2014/main" id="{612FD74A-408B-861D-0901-8745E85F5B4A}"/>
+              </a:ext>
+            </a:extLst>
+          </p:cNvPr>
+          <p:cNvPicPr>
+            <a:picLocks noChangeAspect="1"/>
+          </p:cNvPicPr>
+          <p:nvPr/>
+        </p:nvPicPr>
+        <p:blipFill>
+          <a:blip r:embed="rId4"/>
+          <a:stretch>
+            <a:fillRect/>
+          </a:stretch>
+        </p:blipFill>
+        <p:spPr>
+          <a:xfrm>
+            <a:off x="8230530" y="642493"/>
+            <a:ext cx="3953003" cy="2237139"/>
+          </a:xfrm>
+          <a:prstGeom prst="rect">
+            <a:avLst/>
+          </a:prstGeom>
+        </p:spPr>
+      </p:pic>
+      <p:pic>
+        <p:nvPicPr>
+          <p:cNvPr id="15" name="Picture 14">
+            <a:extLst>
+              <a:ext uri="{FF2B5EF4-FFF2-40B4-BE49-F238E27FC236}">
+                <a16:creationId xmlns:a16="http://schemas.microsoft.com/office/drawing/2014/main" id="{5F4C5F72-D4F7-0D35-37E5-CD84B77D98E6}"/>
+              </a:ext>
+            </a:extLst>
+          </p:cNvPr>
+          <p:cNvPicPr>
+            <a:picLocks noChangeAspect="1"/>
+          </p:cNvPicPr>
+          <p:nvPr/>
+        </p:nvPicPr>
+        <p:blipFill>
+          <a:blip r:embed="rId5"/>
+          <a:stretch>
+            <a:fillRect/>
+          </a:stretch>
+        </p:blipFill>
+        <p:spPr>
+          <a:xfrm>
+            <a:off x="-4980" y="4166938"/>
+            <a:ext cx="3995047" cy="2325475"/>
+          </a:xfrm>
+          <a:prstGeom prst="rect">
+            <a:avLst/>
+          </a:prstGeom>
+        </p:spPr>
+      </p:pic>
+      <p:pic>
+        <p:nvPicPr>
+          <p:cNvPr id="18" name="Picture 17">
+            <a:extLst>
+              <a:ext uri="{FF2B5EF4-FFF2-40B4-BE49-F238E27FC236}">
+                <a16:creationId xmlns:a16="http://schemas.microsoft.com/office/drawing/2014/main" id="{7EB11E96-4F05-79C1-D974-5E2BADFCC9B9}"/>
+              </a:ext>
+            </a:extLst>
+          </p:cNvPr>
+          <p:cNvPicPr>
+            <a:picLocks noChangeAspect="1"/>
+          </p:cNvPicPr>
+          <p:nvPr/>
+        </p:nvPicPr>
+        <p:blipFill>
+          <a:blip r:embed="rId6"/>
+          <a:stretch>
+            <a:fillRect/>
+          </a:stretch>
+        </p:blipFill>
+        <p:spPr>
+          <a:xfrm>
+            <a:off x="4059919" y="4127784"/>
+            <a:ext cx="4111342" cy="2572366"/>
+          </a:xfrm>
+          <a:prstGeom prst="rect">
+            <a:avLst/>
+          </a:prstGeom>
+        </p:spPr>
+      </p:pic>
+      <p:pic>
+        <p:nvPicPr>
+          <p:cNvPr id="23" name="Picture 22">
+            <a:extLst>
+              <a:ext uri="{FF2B5EF4-FFF2-40B4-BE49-F238E27FC236}">
+                <a16:creationId xmlns:a16="http://schemas.microsoft.com/office/drawing/2014/main" id="{89E7A611-C51B-9591-33DD-F7640F40434E}"/>
+              </a:ext>
+            </a:extLst>
+          </p:cNvPr>
+          <p:cNvPicPr>
+            <a:picLocks noChangeAspect="1"/>
+          </p:cNvPicPr>
+          <p:nvPr/>
+        </p:nvPicPr>
+        <p:blipFill>
+          <a:blip r:embed="rId7"/>
+          <a:stretch>
+            <a:fillRect/>
+          </a:stretch>
+        </p:blipFill>
+        <p:spPr>
+          <a:xfrm>
+            <a:off x="8296425" y="4203987"/>
+            <a:ext cx="3804278" cy="2275261"/>
+          </a:xfrm>
+          <a:prstGeom prst="rect">
+            <a:avLst/>
+          </a:prstGeom>
+        </p:spPr>
+      </p:pic>
+    </p:spTree>
+    <p:extLst>
+      <p:ext uri="{BB962C8B-B14F-4D97-AF65-F5344CB8AC3E}">
+        <p14:creationId xmlns:p14="http://schemas.microsoft.com/office/powerpoint/2010/main" val="657176080"/>
+      </p:ext>
+    </p:extLst>
+  </p:cSld>
+  <p:clrMapOvr>
+    <a:masterClrMapping/>
+  </p:clrMapOvr>
+</p:sld>
+</file>
+
+<file path=ppt/slides/slide6.xml><?xml version="1.0" encoding="utf-8"?>
+<p:sld xmlns:a="http://schemas.openxmlformats.org/drawingml/2006/main" xmlns:r="http://schemas.openxmlformats.org/officeDocument/2006/relationships" xmlns:p="http://schemas.openxmlformats.org/presentationml/2006/main">
+  <p:cSld>
+    <p:bg>
+      <p:bgPr>
+        <a:solidFill>
+          <a:schemeClr val="bg1"/>
+        </a:solidFill>
+        <a:effectLst/>
+      </p:bgPr>
+    </p:bg>
+    <p:spTree>
+      <p:nvGrpSpPr>
+        <p:cNvPr id="1" name="">
+          <a:extLst>
+            <a:ext uri="{FF2B5EF4-FFF2-40B4-BE49-F238E27FC236}">
+              <a16:creationId xmlns:a16="http://schemas.microsoft.com/office/drawing/2014/main" id="{DB7950FF-3071-E731-00A9-33A21852BBFA}"/>
+            </a:ext>
+          </a:extLst>
+        </p:cNvPr>
+        <p:cNvGrpSpPr/>
+        <p:nvPr/>
+      </p:nvGrpSpPr>
+      <p:grpSpPr>
+        <a:xfrm>
+          <a:off x="0" y="0"/>
+          <a:ext cx="0" cy="0"/>
+          <a:chOff x="0" y="0"/>
+          <a:chExt cx="0" cy="0"/>
+        </a:xfrm>
+      </p:grpSpPr>
+      <p:sp>
+        <p:nvSpPr>
+          <p:cNvPr id="8" name="TextBox 7">
+            <a:extLst>
+              <a:ext uri="{FF2B5EF4-FFF2-40B4-BE49-F238E27FC236}">
+                <a16:creationId xmlns:a16="http://schemas.microsoft.com/office/drawing/2014/main" id="{34CCA579-FC3A-CEE2-B3DD-5F5698F1C9F9}"/>
+              </a:ext>
+            </a:extLst>
+          </p:cNvPr>
+          <p:cNvSpPr txBox="1"/>
+          <p:nvPr/>
+        </p:nvSpPr>
+        <p:spPr>
+          <a:xfrm>
+            <a:off x="19351" y="0"/>
+            <a:ext cx="548640" cy="584775"/>
+          </a:xfrm>
+          <a:prstGeom prst="rect">
+            <a:avLst/>
+          </a:prstGeom>
+          <a:noFill/>
+        </p:spPr>
+        <p:txBody>
+          <a:bodyPr wrap="square" rtlCol="0">
+            <a:spAutoFit/>
+          </a:bodyPr>
+          <a:lstStyle/>
+          <a:p>
+            <a:r>
+              <a:rPr lang="en-US" sz="3200" b="1" dirty="0"/>
+              <a:t>A</a:t>
+            </a:r>
+          </a:p>
+        </p:txBody>
+      </p:sp>
+      <p:sp>
+        <p:nvSpPr>
+          <p:cNvPr id="9" name="TextBox 8">
+            <a:extLst>
+              <a:ext uri="{FF2B5EF4-FFF2-40B4-BE49-F238E27FC236}">
+                <a16:creationId xmlns:a16="http://schemas.microsoft.com/office/drawing/2014/main" id="{ED60456A-857B-9ACB-252F-E357EDED5FD2}"/>
+              </a:ext>
+            </a:extLst>
+          </p:cNvPr>
+          <p:cNvSpPr txBox="1"/>
+          <p:nvPr/>
+        </p:nvSpPr>
+        <p:spPr>
+          <a:xfrm>
+            <a:off x="2607267" y="0"/>
+            <a:ext cx="548640" cy="584775"/>
+          </a:xfrm>
+          <a:prstGeom prst="rect">
+            <a:avLst/>
+          </a:prstGeom>
+          <a:noFill/>
+        </p:spPr>
+        <p:txBody>
+          <a:bodyPr wrap="square" rtlCol="0">
+            <a:spAutoFit/>
+          </a:bodyPr>
+          <a:lstStyle/>
+          <a:p>
+            <a:r>
+              <a:rPr lang="en-US" sz="3200" b="1" dirty="0"/>
+              <a:t>B</a:t>
+            </a:r>
+          </a:p>
+        </p:txBody>
+      </p:sp>
+      <p:cxnSp>
+        <p:nvCxnSpPr>
+          <p:cNvPr id="11" name="Straight Connector 10">
+            <a:extLst>
+              <a:ext uri="{FF2B5EF4-FFF2-40B4-BE49-F238E27FC236}">
+                <a16:creationId xmlns:a16="http://schemas.microsoft.com/office/drawing/2014/main" id="{D06D6C0C-F0C2-B100-15CA-EF41573F4EFE}"/>
+              </a:ext>
+            </a:extLst>
+          </p:cNvPr>
+          <p:cNvCxnSpPr>
+            <a:cxnSpLocks/>
+          </p:cNvCxnSpPr>
+          <p:nvPr/>
+        </p:nvCxnSpPr>
+        <p:spPr>
+          <a:xfrm>
+            <a:off x="27575" y="3416675"/>
+            <a:ext cx="12192000" cy="24650"/>
+          </a:xfrm>
+          <a:prstGeom prst="line">
+            <a:avLst/>
+          </a:prstGeom>
+          <a:ln w="19050" cap="flat" cmpd="sng" algn="ctr">
+            <a:solidFill>
+              <a:schemeClr val="dk1"/>
+            </a:solidFill>
+            <a:prstDash val="dash"/>
+            <a:round/>
+            <a:headEnd type="none" w="med" len="med"/>
+            <a:tailEnd type="none" w="med" len="med"/>
+          </a:ln>
+        </p:spPr>
+        <p:style>
+          <a:lnRef idx="0">
+            <a:scrgbClr r="0" g="0" b="0"/>
+          </a:lnRef>
+          <a:fillRef idx="0">
+            <a:scrgbClr r="0" g="0" b="0"/>
+          </a:fillRef>
+          <a:effectRef idx="0">
+            <a:scrgbClr r="0" g="0" b="0"/>
+          </a:effectRef>
+          <a:fontRef idx="minor">
+            <a:schemeClr val="tx1"/>
+          </a:fontRef>
+        </p:style>
+      </p:cxnSp>
+      <p:sp>
+        <p:nvSpPr>
+          <p:cNvPr id="21" name="TextBox 20">
+            <a:extLst>
+              <a:ext uri="{FF2B5EF4-FFF2-40B4-BE49-F238E27FC236}">
+                <a16:creationId xmlns:a16="http://schemas.microsoft.com/office/drawing/2014/main" id="{8C22C83A-6711-51EA-140F-F26DED670A69}"/>
+              </a:ext>
+            </a:extLst>
+          </p:cNvPr>
+          <p:cNvSpPr txBox="1"/>
+          <p:nvPr/>
+        </p:nvSpPr>
+        <p:spPr>
+          <a:xfrm>
+            <a:off x="-14517" y="3424479"/>
+            <a:ext cx="548640" cy="584775"/>
+          </a:xfrm>
+          <a:prstGeom prst="rect">
+            <a:avLst/>
+          </a:prstGeom>
+          <a:noFill/>
+        </p:spPr>
+        <p:txBody>
+          <a:bodyPr wrap="square" rtlCol="0">
+            <a:spAutoFit/>
+          </a:bodyPr>
+          <a:lstStyle/>
+          <a:p>
+            <a:r>
+              <a:rPr lang="en-US" sz="3200" b="1" dirty="0"/>
+              <a:t>F</a:t>
+            </a:r>
+          </a:p>
+        </p:txBody>
+      </p:sp>
+      <p:sp>
+        <p:nvSpPr>
+          <p:cNvPr id="22" name="TextBox 21">
+            <a:extLst>
+              <a:ext uri="{FF2B5EF4-FFF2-40B4-BE49-F238E27FC236}">
+                <a16:creationId xmlns:a16="http://schemas.microsoft.com/office/drawing/2014/main" id="{1CE85BDC-4BF8-4D73-247B-A3FC6D7618C5}"/>
+              </a:ext>
+            </a:extLst>
+          </p:cNvPr>
+          <p:cNvSpPr txBox="1"/>
+          <p:nvPr/>
+        </p:nvSpPr>
+        <p:spPr>
+          <a:xfrm>
+            <a:off x="2616197" y="3424479"/>
+            <a:ext cx="548640" cy="584775"/>
+          </a:xfrm>
+          <a:prstGeom prst="rect">
+            <a:avLst/>
+          </a:prstGeom>
+          <a:noFill/>
+        </p:spPr>
+        <p:txBody>
+          <a:bodyPr wrap="square" rtlCol="0">
+            <a:spAutoFit/>
+          </a:bodyPr>
+          <a:lstStyle/>
+          <a:p>
+            <a:r>
+              <a:rPr lang="en-US" sz="3200" b="1" dirty="0"/>
+              <a:t>G</a:t>
+            </a:r>
+          </a:p>
+        </p:txBody>
+      </p:sp>
+      <p:cxnSp>
+        <p:nvCxnSpPr>
+          <p:cNvPr id="26" name="Straight Connector 25">
+            <a:extLst>
+              <a:ext uri="{FF2B5EF4-FFF2-40B4-BE49-F238E27FC236}">
+                <a16:creationId xmlns:a16="http://schemas.microsoft.com/office/drawing/2014/main" id="{C470A528-4143-0CB3-2D0B-78B0E2319874}"/>
+              </a:ext>
+            </a:extLst>
+          </p:cNvPr>
+          <p:cNvCxnSpPr>
+            <a:cxnSpLocks/>
+          </p:cNvCxnSpPr>
+          <p:nvPr/>
+        </p:nvCxnSpPr>
+        <p:spPr>
+          <a:xfrm>
+            <a:off x="2650065" y="-7433"/>
+            <a:ext cx="0" cy="6872867"/>
+          </a:xfrm>
+          <a:prstGeom prst="line">
+            <a:avLst/>
+          </a:prstGeom>
+          <a:ln w="19050" cap="flat" cmpd="sng" algn="ctr">
+            <a:solidFill>
+              <a:schemeClr val="dk1"/>
+            </a:solidFill>
+            <a:prstDash val="dash"/>
+            <a:round/>
+            <a:headEnd type="none" w="med" len="med"/>
+            <a:tailEnd type="none" w="med" len="med"/>
+          </a:ln>
+        </p:spPr>
+        <p:style>
+          <a:lnRef idx="0">
+            <a:scrgbClr r="0" g="0" b="0"/>
+          </a:lnRef>
+          <a:fillRef idx="0">
+            <a:scrgbClr r="0" g="0" b="0"/>
+          </a:fillRef>
+          <a:effectRef idx="0">
+            <a:scrgbClr r="0" g="0" b="0"/>
+          </a:effectRef>
+          <a:fontRef idx="minor">
+            <a:schemeClr val="tx1"/>
+          </a:fontRef>
+        </p:style>
+      </p:cxnSp>
+      <p:sp>
+        <p:nvSpPr>
+          <p:cNvPr id="2" name="TextBox 1">
+            <a:extLst>
+              <a:ext uri="{FF2B5EF4-FFF2-40B4-BE49-F238E27FC236}">
+                <a16:creationId xmlns:a16="http://schemas.microsoft.com/office/drawing/2014/main" id="{858C932A-7D5A-A7BD-BA8F-64628AB463EF}"/>
+              </a:ext>
+            </a:extLst>
+          </p:cNvPr>
+          <p:cNvSpPr txBox="1"/>
+          <p:nvPr/>
+        </p:nvSpPr>
+        <p:spPr>
+          <a:xfrm>
+            <a:off x="5156202" y="0"/>
+            <a:ext cx="548640" cy="584775"/>
+          </a:xfrm>
+          <a:prstGeom prst="rect">
+            <a:avLst/>
+          </a:prstGeom>
+          <a:noFill/>
+        </p:spPr>
+        <p:txBody>
+          <a:bodyPr wrap="square" rtlCol="0">
+            <a:spAutoFit/>
+          </a:bodyPr>
+          <a:lstStyle/>
+          <a:p>
+            <a:r>
+              <a:rPr lang="en-US" sz="3200" b="1" dirty="0"/>
+              <a:t>C</a:t>
+            </a:r>
+          </a:p>
+        </p:txBody>
+      </p:sp>
+      <p:sp>
+        <p:nvSpPr>
+          <p:cNvPr id="4" name="TextBox 3">
+            <a:extLst>
+              <a:ext uri="{FF2B5EF4-FFF2-40B4-BE49-F238E27FC236}">
+                <a16:creationId xmlns:a16="http://schemas.microsoft.com/office/drawing/2014/main" id="{115257A0-A505-1633-ADEC-53BBA3E57560}"/>
+              </a:ext>
+            </a:extLst>
+          </p:cNvPr>
+          <p:cNvSpPr txBox="1"/>
+          <p:nvPr/>
+        </p:nvSpPr>
+        <p:spPr>
+          <a:xfrm>
+            <a:off x="5198075" y="3424479"/>
+            <a:ext cx="548640" cy="584775"/>
+          </a:xfrm>
+          <a:prstGeom prst="rect">
+            <a:avLst/>
+          </a:prstGeom>
+          <a:noFill/>
+        </p:spPr>
+        <p:txBody>
+          <a:bodyPr wrap="square" rtlCol="0">
+            <a:spAutoFit/>
+          </a:bodyPr>
+          <a:lstStyle/>
+          <a:p>
+            <a:r>
+              <a:rPr lang="en-US" sz="3200" b="1" dirty="0"/>
+              <a:t>H</a:t>
+            </a:r>
+          </a:p>
+        </p:txBody>
+      </p:sp>
+      <p:cxnSp>
+        <p:nvCxnSpPr>
+          <p:cNvPr id="6" name="Straight Connector 5">
+            <a:extLst>
+              <a:ext uri="{FF2B5EF4-FFF2-40B4-BE49-F238E27FC236}">
+                <a16:creationId xmlns:a16="http://schemas.microsoft.com/office/drawing/2014/main" id="{1CC500DC-A80D-423C-4BDB-C49C4787DAD4}"/>
+              </a:ext>
+            </a:extLst>
+          </p:cNvPr>
+          <p:cNvCxnSpPr>
+            <a:cxnSpLocks/>
+          </p:cNvCxnSpPr>
+          <p:nvPr/>
+        </p:nvCxnSpPr>
+        <p:spPr>
+          <a:xfrm>
+            <a:off x="5190070" y="-7433"/>
+            <a:ext cx="0" cy="6872867"/>
+          </a:xfrm>
+          <a:prstGeom prst="line">
+            <a:avLst/>
+          </a:prstGeom>
+          <a:ln w="19050" cap="flat" cmpd="sng" algn="ctr">
+            <a:solidFill>
+              <a:schemeClr val="dk1"/>
+            </a:solidFill>
+            <a:prstDash val="dash"/>
+            <a:round/>
+            <a:headEnd type="none" w="med" len="med"/>
+            <a:tailEnd type="none" w="med" len="med"/>
+          </a:ln>
+        </p:spPr>
+        <p:style>
+          <a:lnRef idx="0">
+            <a:scrgbClr r="0" g="0" b="0"/>
+          </a:lnRef>
+          <a:fillRef idx="0">
+            <a:scrgbClr r="0" g="0" b="0"/>
+          </a:fillRef>
+          <a:effectRef idx="0">
+            <a:scrgbClr r="0" g="0" b="0"/>
+          </a:effectRef>
+          <a:fontRef idx="minor">
+            <a:schemeClr val="tx1"/>
+          </a:fontRef>
+        </p:style>
+      </p:cxnSp>
+      <p:cxnSp>
+        <p:nvCxnSpPr>
+          <p:cNvPr id="10" name="Straight Connector 9">
+            <a:extLst>
+              <a:ext uri="{FF2B5EF4-FFF2-40B4-BE49-F238E27FC236}">
+                <a16:creationId xmlns:a16="http://schemas.microsoft.com/office/drawing/2014/main" id="{89CA52EC-FF61-6C22-9139-A15F78DA9DFB}"/>
+              </a:ext>
+            </a:extLst>
+          </p:cNvPr>
+          <p:cNvCxnSpPr>
+            <a:cxnSpLocks/>
+          </p:cNvCxnSpPr>
+          <p:nvPr/>
+        </p:nvCxnSpPr>
+        <p:spPr>
+          <a:xfrm>
+            <a:off x="7730075" y="-7433"/>
+            <a:ext cx="0" cy="6872867"/>
+          </a:xfrm>
+          <a:prstGeom prst="line">
+            <a:avLst/>
+          </a:prstGeom>
+          <a:ln w="19050" cap="flat" cmpd="sng" algn="ctr">
+            <a:solidFill>
+              <a:schemeClr val="dk1"/>
+            </a:solidFill>
+            <a:prstDash val="dash"/>
+            <a:round/>
+            <a:headEnd type="none" w="med" len="med"/>
+            <a:tailEnd type="none" w="med" len="med"/>
+          </a:ln>
+        </p:spPr>
+        <p:style>
+          <a:lnRef idx="0">
+            <a:scrgbClr r="0" g="0" b="0"/>
+          </a:lnRef>
+          <a:fillRef idx="0">
+            <a:scrgbClr r="0" g="0" b="0"/>
+          </a:fillRef>
+          <a:effectRef idx="0">
+            <a:scrgbClr r="0" g="0" b="0"/>
+          </a:effectRef>
+          <a:fontRef idx="minor">
+            <a:schemeClr val="tx1"/>
+          </a:fontRef>
+        </p:style>
+      </p:cxnSp>
+      <p:cxnSp>
+        <p:nvCxnSpPr>
+          <p:cNvPr id="12" name="Straight Connector 11">
+            <a:extLst>
+              <a:ext uri="{FF2B5EF4-FFF2-40B4-BE49-F238E27FC236}">
+                <a16:creationId xmlns:a16="http://schemas.microsoft.com/office/drawing/2014/main" id="{13DD44C7-C93E-7FCE-A38B-FE478C250B4F}"/>
+              </a:ext>
+            </a:extLst>
+          </p:cNvPr>
+          <p:cNvCxnSpPr>
+            <a:cxnSpLocks/>
+          </p:cNvCxnSpPr>
+          <p:nvPr/>
+        </p:nvCxnSpPr>
+        <p:spPr>
+          <a:xfrm>
+            <a:off x="10270081" y="-7433"/>
+            <a:ext cx="0" cy="6872867"/>
+          </a:xfrm>
+          <a:prstGeom prst="line">
+            <a:avLst/>
+          </a:prstGeom>
+          <a:ln w="19050" cap="flat" cmpd="sng" algn="ctr">
+            <a:solidFill>
+              <a:schemeClr val="dk1"/>
+            </a:solidFill>
+            <a:prstDash val="dash"/>
+            <a:round/>
+            <a:headEnd type="none" w="med" len="med"/>
+            <a:tailEnd type="none" w="med" len="med"/>
+          </a:ln>
+        </p:spPr>
+        <p:style>
+          <a:lnRef idx="0">
+            <a:scrgbClr r="0" g="0" b="0"/>
+          </a:lnRef>
+          <a:fillRef idx="0">
+            <a:scrgbClr r="0" g="0" b="0"/>
+          </a:fillRef>
+          <a:effectRef idx="0">
+            <a:scrgbClr r="0" g="0" b="0"/>
+          </a:effectRef>
+          <a:fontRef idx="minor">
+            <a:schemeClr val="tx1"/>
+          </a:fontRef>
+        </p:style>
+      </p:cxnSp>
+      <p:sp>
+        <p:nvSpPr>
+          <p:cNvPr id="13" name="TextBox 12">
+            <a:extLst>
+              <a:ext uri="{FF2B5EF4-FFF2-40B4-BE49-F238E27FC236}">
+                <a16:creationId xmlns:a16="http://schemas.microsoft.com/office/drawing/2014/main" id="{83773BEE-E9C0-211C-71D5-203CCA67FF7F}"/>
+              </a:ext>
+            </a:extLst>
+          </p:cNvPr>
+          <p:cNvSpPr txBox="1"/>
+          <p:nvPr/>
+        </p:nvSpPr>
+        <p:spPr>
+          <a:xfrm>
+            <a:off x="7688203" y="0"/>
+            <a:ext cx="548640" cy="584775"/>
+          </a:xfrm>
+          <a:prstGeom prst="rect">
+            <a:avLst/>
+          </a:prstGeom>
+          <a:noFill/>
+        </p:spPr>
+        <p:txBody>
+          <a:bodyPr wrap="square" rtlCol="0">
+            <a:spAutoFit/>
+          </a:bodyPr>
+          <a:lstStyle/>
+          <a:p>
+            <a:r>
+              <a:rPr lang="en-US" sz="3200" b="1" dirty="0"/>
+              <a:t>D</a:t>
+            </a:r>
+          </a:p>
+        </p:txBody>
+      </p:sp>
+      <p:sp>
+        <p:nvSpPr>
+          <p:cNvPr id="15" name="TextBox 14">
+            <a:extLst>
+              <a:ext uri="{FF2B5EF4-FFF2-40B4-BE49-F238E27FC236}">
+                <a16:creationId xmlns:a16="http://schemas.microsoft.com/office/drawing/2014/main" id="{5E256250-EED8-28D0-EE03-1DA3AEEB582A}"/>
+              </a:ext>
+            </a:extLst>
+          </p:cNvPr>
+          <p:cNvSpPr txBox="1"/>
+          <p:nvPr/>
+        </p:nvSpPr>
+        <p:spPr>
+          <a:xfrm>
+            <a:off x="10228207" y="0"/>
+            <a:ext cx="548640" cy="584775"/>
+          </a:xfrm>
+          <a:prstGeom prst="rect">
+            <a:avLst/>
+          </a:prstGeom>
+          <a:noFill/>
+        </p:spPr>
+        <p:txBody>
+          <a:bodyPr wrap="square" rtlCol="0">
+            <a:spAutoFit/>
+          </a:bodyPr>
+          <a:lstStyle/>
+          <a:p>
+            <a:r>
+              <a:rPr lang="en-US" sz="3200" b="1" dirty="0"/>
+              <a:t>E</a:t>
+            </a:r>
+          </a:p>
+        </p:txBody>
+      </p:sp>
+      <p:sp>
+        <p:nvSpPr>
+          <p:cNvPr id="16" name="TextBox 15">
+            <a:extLst>
+              <a:ext uri="{FF2B5EF4-FFF2-40B4-BE49-F238E27FC236}">
+                <a16:creationId xmlns:a16="http://schemas.microsoft.com/office/drawing/2014/main" id="{FF779253-DB89-4E86-8F45-F7DBCC5982AB}"/>
+              </a:ext>
+            </a:extLst>
+          </p:cNvPr>
+          <p:cNvSpPr txBox="1"/>
+          <p:nvPr/>
+        </p:nvSpPr>
+        <p:spPr>
+          <a:xfrm>
+            <a:off x="7753789" y="3424479"/>
+            <a:ext cx="548640" cy="584775"/>
+          </a:xfrm>
+          <a:prstGeom prst="rect">
+            <a:avLst/>
+          </a:prstGeom>
+          <a:noFill/>
+        </p:spPr>
+        <p:txBody>
+          <a:bodyPr wrap="square" rtlCol="0">
+            <a:spAutoFit/>
+          </a:bodyPr>
+          <a:lstStyle/>
+          <a:p>
+            <a:r>
+              <a:rPr lang="en-US" sz="3200" b="1" dirty="0"/>
+              <a:t>I</a:t>
+            </a:r>
+          </a:p>
+        </p:txBody>
+      </p:sp>
+      <p:sp>
+        <p:nvSpPr>
+          <p:cNvPr id="17" name="TextBox 16">
+            <a:extLst>
+              <a:ext uri="{FF2B5EF4-FFF2-40B4-BE49-F238E27FC236}">
+                <a16:creationId xmlns:a16="http://schemas.microsoft.com/office/drawing/2014/main" id="{A6D99754-F8B1-9D46-3099-3B428D914C5A}"/>
+              </a:ext>
+            </a:extLst>
+          </p:cNvPr>
+          <p:cNvSpPr txBox="1"/>
+          <p:nvPr/>
+        </p:nvSpPr>
+        <p:spPr>
+          <a:xfrm>
+            <a:off x="10250237" y="3424479"/>
+            <a:ext cx="548640" cy="584775"/>
+          </a:xfrm>
+          <a:prstGeom prst="rect">
+            <a:avLst/>
+          </a:prstGeom>
+          <a:noFill/>
+        </p:spPr>
+        <p:txBody>
+          <a:bodyPr wrap="square" rtlCol="0">
+            <a:spAutoFit/>
+          </a:bodyPr>
+          <a:lstStyle/>
+          <a:p>
+            <a:r>
+              <a:rPr lang="en-US" sz="3200" b="1" dirty="0"/>
+              <a:t>J</a:t>
+            </a:r>
+          </a:p>
+        </p:txBody>
+      </p:sp>
+    </p:spTree>
+    <p:extLst>
+      <p:ext uri="{BB962C8B-B14F-4D97-AF65-F5344CB8AC3E}">
+        <p14:creationId xmlns:p14="http://schemas.microsoft.com/office/powerpoint/2010/main" val="1973511414"/>
+      </p:ext>
+    </p:extLst>
+  </p:cSld>
+  <p:clrMapOvr>
+    <a:masterClrMapping/>
+  </p:clrMapOvr>
+</p:sld>
+</file>
+
+<file path=ppt/slides/slide7.xml><?xml version="1.0" encoding="utf-8"?>
+<p:sld xmlns:a="http://schemas.openxmlformats.org/drawingml/2006/main" xmlns:r="http://schemas.openxmlformats.org/officeDocument/2006/relationships" xmlns:p="http://schemas.openxmlformats.org/presentationml/2006/main">
+  <p:cSld>
+    <p:bg>
+      <p:bgPr>
+        <a:solidFill>
+          <a:schemeClr val="bg1"/>
+        </a:solidFill>
+        <a:effectLst/>
+      </p:bgPr>
+    </p:bg>
+    <p:spTree>
+      <p:nvGrpSpPr>
+        <p:cNvPr id="1" name="">
+          <a:extLst>
+            <a:ext uri="{FF2B5EF4-FFF2-40B4-BE49-F238E27FC236}">
               <a16:creationId xmlns:a16="http://schemas.microsoft.com/office/drawing/2014/main" id="{067F4A04-97BC-79D8-2181-BB1B4BCFFB0E}"/>
             </a:ext>
           </a:extLst>

</xml_diff>

<commit_message>
improve plot for step2
</commit_message>
<xml_diff>
--- a/Reports/Step1/figures.pptx
+++ b/Reports/Step1/figures.pptx
@@ -12,6 +12,7 @@
     <p:sldId id="262" r:id="rId6"/>
     <p:sldId id="260" r:id="rId7"/>
     <p:sldId id="259" r:id="rId8"/>
+    <p:sldId id="263" r:id="rId9"/>
   </p:sldIdLst>
   <p:sldSz cx="12192000" cy="6858000"/>
   <p:notesSz cx="6858000" cy="9144000"/>
@@ -265,7 +266,7 @@
           <a:p>
             <a:fld id="{070C54B2-02AF-4F32-9526-487D6CDB273B}" type="datetimeFigureOut">
               <a:rPr lang="en-US" smtClean="0"/>
-              <a:t>10/7/2025</a:t>
+              <a:t>10/14/2025</a:t>
             </a:fld>
             <a:endParaRPr lang="en-US"/>
           </a:p>
@@ -463,7 +464,7 @@
           <a:p>
             <a:fld id="{070C54B2-02AF-4F32-9526-487D6CDB273B}" type="datetimeFigureOut">
               <a:rPr lang="en-US" smtClean="0"/>
-              <a:t>10/7/2025</a:t>
+              <a:t>10/14/2025</a:t>
             </a:fld>
             <a:endParaRPr lang="en-US"/>
           </a:p>
@@ -671,7 +672,7 @@
           <a:p>
             <a:fld id="{070C54B2-02AF-4F32-9526-487D6CDB273B}" type="datetimeFigureOut">
               <a:rPr lang="en-US" smtClean="0"/>
-              <a:t>10/7/2025</a:t>
+              <a:t>10/14/2025</a:t>
             </a:fld>
             <a:endParaRPr lang="en-US"/>
           </a:p>
@@ -869,7 +870,7 @@
           <a:p>
             <a:fld id="{070C54B2-02AF-4F32-9526-487D6CDB273B}" type="datetimeFigureOut">
               <a:rPr lang="en-US" smtClean="0"/>
-              <a:t>10/7/2025</a:t>
+              <a:t>10/14/2025</a:t>
             </a:fld>
             <a:endParaRPr lang="en-US"/>
           </a:p>
@@ -1144,7 +1145,7 @@
           <a:p>
             <a:fld id="{070C54B2-02AF-4F32-9526-487D6CDB273B}" type="datetimeFigureOut">
               <a:rPr lang="en-US" smtClean="0"/>
-              <a:t>10/7/2025</a:t>
+              <a:t>10/14/2025</a:t>
             </a:fld>
             <a:endParaRPr lang="en-US"/>
           </a:p>
@@ -1409,7 +1410,7 @@
           <a:p>
             <a:fld id="{070C54B2-02AF-4F32-9526-487D6CDB273B}" type="datetimeFigureOut">
               <a:rPr lang="en-US" smtClean="0"/>
-              <a:t>10/7/2025</a:t>
+              <a:t>10/14/2025</a:t>
             </a:fld>
             <a:endParaRPr lang="en-US"/>
           </a:p>
@@ -1821,7 +1822,7 @@
           <a:p>
             <a:fld id="{070C54B2-02AF-4F32-9526-487D6CDB273B}" type="datetimeFigureOut">
               <a:rPr lang="en-US" smtClean="0"/>
-              <a:t>10/7/2025</a:t>
+              <a:t>10/14/2025</a:t>
             </a:fld>
             <a:endParaRPr lang="en-US"/>
           </a:p>
@@ -1962,7 +1963,7 @@
           <a:p>
             <a:fld id="{070C54B2-02AF-4F32-9526-487D6CDB273B}" type="datetimeFigureOut">
               <a:rPr lang="en-US" smtClean="0"/>
-              <a:t>10/7/2025</a:t>
+              <a:t>10/14/2025</a:t>
             </a:fld>
             <a:endParaRPr lang="en-US"/>
           </a:p>
@@ -2075,7 +2076,7 @@
           <a:p>
             <a:fld id="{070C54B2-02AF-4F32-9526-487D6CDB273B}" type="datetimeFigureOut">
               <a:rPr lang="en-US" smtClean="0"/>
-              <a:t>10/7/2025</a:t>
+              <a:t>10/14/2025</a:t>
             </a:fld>
             <a:endParaRPr lang="en-US"/>
           </a:p>
@@ -2386,7 +2387,7 @@
           <a:p>
             <a:fld id="{070C54B2-02AF-4F32-9526-487D6CDB273B}" type="datetimeFigureOut">
               <a:rPr lang="en-US" smtClean="0"/>
-              <a:t>10/7/2025</a:t>
+              <a:t>10/14/2025</a:t>
             </a:fld>
             <a:endParaRPr lang="en-US"/>
           </a:p>
@@ -2674,7 +2675,7 @@
           <a:p>
             <a:fld id="{070C54B2-02AF-4F32-9526-487D6CDB273B}" type="datetimeFigureOut">
               <a:rPr lang="en-US" smtClean="0"/>
-              <a:t>10/7/2025</a:t>
+              <a:t>10/14/2025</a:t>
             </a:fld>
             <a:endParaRPr lang="en-US"/>
           </a:p>
@@ -2915,7 +2916,7 @@
           <a:p>
             <a:fld id="{070C54B2-02AF-4F32-9526-487D6CDB273B}" type="datetimeFigureOut">
               <a:rPr lang="en-US" smtClean="0"/>
-              <a:t>10/7/2025</a:t>
+              <a:t>10/14/2025</a:t>
             </a:fld>
             <a:endParaRPr lang="en-US"/>
           </a:p>
@@ -6364,6 +6365,212 @@
 </p:sld>
 </file>
 
+<file path=ppt/slides/slide8.xml><?xml version="1.0" encoding="utf-8"?>
+<p:sld xmlns:a="http://schemas.openxmlformats.org/drawingml/2006/main" xmlns:r="http://schemas.openxmlformats.org/officeDocument/2006/relationships" xmlns:p="http://schemas.openxmlformats.org/presentationml/2006/main">
+  <p:cSld>
+    <p:spTree>
+      <p:nvGrpSpPr>
+        <p:cNvPr id="1" name=""/>
+        <p:cNvGrpSpPr/>
+        <p:nvPr/>
+      </p:nvGrpSpPr>
+      <p:grpSpPr>
+        <a:xfrm>
+          <a:off x="0" y="0"/>
+          <a:ext cx="0" cy="0"/>
+          <a:chOff x="0" y="0"/>
+          <a:chExt cx="0" cy="0"/>
+        </a:xfrm>
+      </p:grpSpPr>
+      <p:pic>
+        <p:nvPicPr>
+          <p:cNvPr id="5" name="Picture 4" descr="A close-up of a graph&#10;&#10;AI-generated content may be incorrect.">
+            <a:extLst>
+              <a:ext uri="{FF2B5EF4-FFF2-40B4-BE49-F238E27FC236}">
+                <a16:creationId xmlns:a16="http://schemas.microsoft.com/office/drawing/2014/main" id="{19F11027-94DF-DBB2-AC04-B2C469565C7B}"/>
+              </a:ext>
+            </a:extLst>
+          </p:cNvPr>
+          <p:cNvPicPr>
+            <a:picLocks noChangeAspect="1"/>
+          </p:cNvPicPr>
+          <p:nvPr/>
+        </p:nvPicPr>
+        <p:blipFill>
+          <a:blip r:embed="rId2">
+            <a:extLst>
+              <a:ext uri="{28A0092B-C50C-407E-A947-70E740481C1C}">
+                <a14:useLocalDpi xmlns:a14="http://schemas.microsoft.com/office/drawing/2010/main" val="0"/>
+              </a:ext>
+            </a:extLst>
+          </a:blip>
+          <a:stretch>
+            <a:fillRect/>
+          </a:stretch>
+        </p:blipFill>
+        <p:spPr>
+          <a:xfrm>
+            <a:off x="901216" y="0"/>
+            <a:ext cx="10389568" cy="6858000"/>
+          </a:xfrm>
+          <a:prstGeom prst="rect">
+            <a:avLst/>
+          </a:prstGeom>
+        </p:spPr>
+      </p:pic>
+      <p:sp>
+        <p:nvSpPr>
+          <p:cNvPr id="13" name="TextBox 12">
+            <a:extLst>
+              <a:ext uri="{FF2B5EF4-FFF2-40B4-BE49-F238E27FC236}">
+                <a16:creationId xmlns:a16="http://schemas.microsoft.com/office/drawing/2014/main" id="{9C55674A-1AE7-A274-D14D-D0B450A99306}"/>
+              </a:ext>
+            </a:extLst>
+          </p:cNvPr>
+          <p:cNvSpPr txBox="1"/>
+          <p:nvPr/>
+        </p:nvSpPr>
+        <p:spPr>
+          <a:xfrm>
+            <a:off x="696493" y="397933"/>
+            <a:ext cx="548640" cy="584775"/>
+          </a:xfrm>
+          <a:prstGeom prst="rect">
+            <a:avLst/>
+          </a:prstGeom>
+          <a:noFill/>
+        </p:spPr>
+        <p:txBody>
+          <a:bodyPr wrap="square" rtlCol="0">
+            <a:spAutoFit/>
+          </a:bodyPr>
+          <a:lstStyle/>
+          <a:p>
+            <a:r>
+              <a:rPr lang="en-US" sz="3200" b="1" dirty="0"/>
+              <a:t>A</a:t>
+            </a:r>
+          </a:p>
+        </p:txBody>
+      </p:sp>
+      <p:sp>
+        <p:nvSpPr>
+          <p:cNvPr id="14" name="TextBox 13">
+            <a:extLst>
+              <a:ext uri="{FF2B5EF4-FFF2-40B4-BE49-F238E27FC236}">
+                <a16:creationId xmlns:a16="http://schemas.microsoft.com/office/drawing/2014/main" id="{49FD460D-8253-B87A-FB31-8DC99686CD1C}"/>
+              </a:ext>
+            </a:extLst>
+          </p:cNvPr>
+          <p:cNvSpPr txBox="1"/>
+          <p:nvPr/>
+        </p:nvSpPr>
+        <p:spPr>
+          <a:xfrm>
+            <a:off x="5926752" y="397933"/>
+            <a:ext cx="548640" cy="584775"/>
+          </a:xfrm>
+          <a:prstGeom prst="rect">
+            <a:avLst/>
+          </a:prstGeom>
+          <a:noFill/>
+        </p:spPr>
+        <p:txBody>
+          <a:bodyPr wrap="square" rtlCol="0">
+            <a:spAutoFit/>
+          </a:bodyPr>
+          <a:lstStyle/>
+          <a:p>
+            <a:r>
+              <a:rPr lang="en-US" sz="3200" b="1" dirty="0"/>
+              <a:t>B</a:t>
+            </a:r>
+          </a:p>
+        </p:txBody>
+      </p:sp>
+      <p:sp>
+        <p:nvSpPr>
+          <p:cNvPr id="15" name="TextBox 14">
+            <a:extLst>
+              <a:ext uri="{FF2B5EF4-FFF2-40B4-BE49-F238E27FC236}">
+                <a16:creationId xmlns:a16="http://schemas.microsoft.com/office/drawing/2014/main" id="{570D2D0E-090B-6D7F-9F96-E71F2B91F6D4}"/>
+              </a:ext>
+            </a:extLst>
+          </p:cNvPr>
+          <p:cNvSpPr txBox="1"/>
+          <p:nvPr/>
+        </p:nvSpPr>
+        <p:spPr>
+          <a:xfrm>
+            <a:off x="696493" y="3132667"/>
+            <a:ext cx="548640" cy="584775"/>
+          </a:xfrm>
+          <a:prstGeom prst="rect">
+            <a:avLst/>
+          </a:prstGeom>
+          <a:noFill/>
+        </p:spPr>
+        <p:txBody>
+          <a:bodyPr wrap="square" rtlCol="0">
+            <a:spAutoFit/>
+          </a:bodyPr>
+          <a:lstStyle/>
+          <a:p>
+            <a:r>
+              <a:rPr lang="en-US" sz="3200" b="1" dirty="0"/>
+              <a:t>C</a:t>
+            </a:r>
+          </a:p>
+        </p:txBody>
+      </p:sp>
+      <p:sp>
+        <p:nvSpPr>
+          <p:cNvPr id="16" name="TextBox 15">
+            <a:extLst>
+              <a:ext uri="{FF2B5EF4-FFF2-40B4-BE49-F238E27FC236}">
+                <a16:creationId xmlns:a16="http://schemas.microsoft.com/office/drawing/2014/main" id="{95DCE6EB-92A1-C661-5902-B76342434721}"/>
+              </a:ext>
+            </a:extLst>
+          </p:cNvPr>
+          <p:cNvSpPr txBox="1"/>
+          <p:nvPr/>
+        </p:nvSpPr>
+        <p:spPr>
+          <a:xfrm>
+            <a:off x="5926752" y="2937933"/>
+            <a:ext cx="548640" cy="584775"/>
+          </a:xfrm>
+          <a:prstGeom prst="rect">
+            <a:avLst/>
+          </a:prstGeom>
+          <a:noFill/>
+        </p:spPr>
+        <p:txBody>
+          <a:bodyPr wrap="square" rtlCol="0">
+            <a:spAutoFit/>
+          </a:bodyPr>
+          <a:lstStyle/>
+          <a:p>
+            <a:r>
+              <a:rPr lang="en-US" sz="3200" b="1" dirty="0"/>
+              <a:t>D</a:t>
+            </a:r>
+          </a:p>
+        </p:txBody>
+      </p:sp>
+    </p:spTree>
+    <p:extLst>
+      <p:ext uri="{BB962C8B-B14F-4D97-AF65-F5344CB8AC3E}">
+        <p14:creationId xmlns:p14="http://schemas.microsoft.com/office/powerpoint/2010/main" val="1607299825"/>
+      </p:ext>
+    </p:extLst>
+  </p:cSld>
+  <p:clrMapOvr>
+    <a:masterClrMapping/>
+  </p:clrMapOvr>
+</p:sld>
+</file>
+
 <file path=ppt/theme/theme1.xml><?xml version="1.0" encoding="utf-8"?>
 <a:theme xmlns:a="http://schemas.openxmlformats.org/drawingml/2006/main" name="Office Theme">
   <a:themeElements>

</xml_diff>

<commit_message>
clean repo some more
</commit_message>
<xml_diff>
--- a/Reports/Step1/figures.pptx
+++ b/Reports/Step1/figures.pptx
@@ -12,7 +12,10 @@
     <p:sldId id="262" r:id="rId6"/>
     <p:sldId id="260" r:id="rId7"/>
     <p:sldId id="259" r:id="rId8"/>
-    <p:sldId id="263" r:id="rId9"/>
+    <p:sldId id="264" r:id="rId9"/>
+    <p:sldId id="265" r:id="rId10"/>
+    <p:sldId id="266" r:id="rId11"/>
+    <p:sldId id="263" r:id="rId12"/>
   </p:sldIdLst>
   <p:sldSz cx="12192000" cy="6858000"/>
   <p:notesSz cx="6858000" cy="9144000"/>
@@ -3529,6 +3532,401 @@
 </p:sld>
 </file>
 
+<file path=ppt/slides/slide10.xml><?xml version="1.0" encoding="utf-8"?>
+<p:sld xmlns:a="http://schemas.openxmlformats.org/drawingml/2006/main" xmlns:r="http://schemas.openxmlformats.org/officeDocument/2006/relationships" xmlns:p="http://schemas.openxmlformats.org/presentationml/2006/main">
+  <p:cSld>
+    <p:bg>
+      <p:bgPr>
+        <a:solidFill>
+          <a:schemeClr val="bg1"/>
+        </a:solidFill>
+        <a:effectLst/>
+      </p:bgPr>
+    </p:bg>
+    <p:spTree>
+      <p:nvGrpSpPr>
+        <p:cNvPr id="1" name="">
+          <a:extLst>
+            <a:ext uri="{FF2B5EF4-FFF2-40B4-BE49-F238E27FC236}">
+              <a16:creationId xmlns:a16="http://schemas.microsoft.com/office/drawing/2014/main" id="{BE3CC694-FCD2-8DBF-980F-07D8734EA8E0}"/>
+            </a:ext>
+          </a:extLst>
+        </p:cNvPr>
+        <p:cNvGrpSpPr/>
+        <p:nvPr/>
+      </p:nvGrpSpPr>
+      <p:grpSpPr>
+        <a:xfrm>
+          <a:off x="0" y="0"/>
+          <a:ext cx="0" cy="0"/>
+          <a:chOff x="0" y="0"/>
+          <a:chExt cx="0" cy="0"/>
+        </a:xfrm>
+      </p:grpSpPr>
+      <p:sp>
+        <p:nvSpPr>
+          <p:cNvPr id="8" name="TextBox 7">
+            <a:extLst>
+              <a:ext uri="{FF2B5EF4-FFF2-40B4-BE49-F238E27FC236}">
+                <a16:creationId xmlns:a16="http://schemas.microsoft.com/office/drawing/2014/main" id="{3071DC13-6BD6-06A3-32D5-E50BC5F2118C}"/>
+              </a:ext>
+            </a:extLst>
+          </p:cNvPr>
+          <p:cNvSpPr txBox="1"/>
+          <p:nvPr/>
+        </p:nvSpPr>
+        <p:spPr>
+          <a:xfrm>
+            <a:off x="314958" y="935548"/>
+            <a:ext cx="548640" cy="707886"/>
+          </a:xfrm>
+          <a:prstGeom prst="rect">
+            <a:avLst/>
+          </a:prstGeom>
+          <a:noFill/>
+        </p:spPr>
+        <p:txBody>
+          <a:bodyPr wrap="square" rtlCol="0">
+            <a:spAutoFit/>
+          </a:bodyPr>
+          <a:lstStyle/>
+          <a:p>
+            <a:r>
+              <a:rPr lang="en-US" sz="4000" b="1" dirty="0"/>
+              <a:t>A</a:t>
+            </a:r>
+          </a:p>
+        </p:txBody>
+      </p:sp>
+      <p:sp>
+        <p:nvSpPr>
+          <p:cNvPr id="9" name="TextBox 8">
+            <a:extLst>
+              <a:ext uri="{FF2B5EF4-FFF2-40B4-BE49-F238E27FC236}">
+                <a16:creationId xmlns:a16="http://schemas.microsoft.com/office/drawing/2014/main" id="{951E8D49-A0E4-D39D-B683-037C4F7F14A2}"/>
+              </a:ext>
+            </a:extLst>
+          </p:cNvPr>
+          <p:cNvSpPr txBox="1"/>
+          <p:nvPr/>
+        </p:nvSpPr>
+        <p:spPr>
+          <a:xfrm>
+            <a:off x="5811520" y="935548"/>
+            <a:ext cx="548640" cy="707886"/>
+          </a:xfrm>
+          <a:prstGeom prst="rect">
+            <a:avLst/>
+          </a:prstGeom>
+          <a:noFill/>
+        </p:spPr>
+        <p:txBody>
+          <a:bodyPr wrap="square" rtlCol="0">
+            <a:spAutoFit/>
+          </a:bodyPr>
+          <a:lstStyle/>
+          <a:p>
+            <a:r>
+              <a:rPr lang="en-US" sz="4000" b="1" dirty="0"/>
+              <a:t>B</a:t>
+            </a:r>
+          </a:p>
+        </p:txBody>
+      </p:sp>
+      <p:cxnSp>
+        <p:nvCxnSpPr>
+          <p:cNvPr id="11" name="Straight Connector 10">
+            <a:extLst>
+              <a:ext uri="{FF2B5EF4-FFF2-40B4-BE49-F238E27FC236}">
+                <a16:creationId xmlns:a16="http://schemas.microsoft.com/office/drawing/2014/main" id="{F61D1B1A-B652-18CF-6C43-6A45F2956671}"/>
+              </a:ext>
+            </a:extLst>
+          </p:cNvPr>
+          <p:cNvCxnSpPr/>
+          <p:nvPr/>
+        </p:nvCxnSpPr>
+        <p:spPr>
+          <a:xfrm>
+            <a:off x="5738710" y="558800"/>
+            <a:ext cx="0" cy="5655733"/>
+          </a:xfrm>
+          <a:prstGeom prst="line">
+            <a:avLst/>
+          </a:prstGeom>
+          <a:ln w="19050" cap="flat" cmpd="sng" algn="ctr">
+            <a:solidFill>
+              <a:schemeClr val="dk1"/>
+            </a:solidFill>
+            <a:prstDash val="dash"/>
+            <a:round/>
+            <a:headEnd type="none" w="med" len="med"/>
+            <a:tailEnd type="none" w="med" len="med"/>
+          </a:ln>
+        </p:spPr>
+        <p:style>
+          <a:lnRef idx="0">
+            <a:scrgbClr r="0" g="0" b="0"/>
+          </a:lnRef>
+          <a:fillRef idx="0">
+            <a:scrgbClr r="0" g="0" b="0"/>
+          </a:fillRef>
+          <a:effectRef idx="0">
+            <a:scrgbClr r="0" g="0" b="0"/>
+          </a:effectRef>
+          <a:fontRef idx="minor">
+            <a:schemeClr val="tx1"/>
+          </a:fontRef>
+        </p:style>
+      </p:cxnSp>
+      <p:pic>
+        <p:nvPicPr>
+          <p:cNvPr id="4" name="Picture 3">
+            <a:extLst>
+              <a:ext uri="{FF2B5EF4-FFF2-40B4-BE49-F238E27FC236}">
+                <a16:creationId xmlns:a16="http://schemas.microsoft.com/office/drawing/2014/main" id="{E3AE3B11-AA85-522A-FAAE-CDF61F82CF49}"/>
+              </a:ext>
+            </a:extLst>
+          </p:cNvPr>
+          <p:cNvPicPr>
+            <a:picLocks noChangeAspect="1"/>
+          </p:cNvPicPr>
+          <p:nvPr/>
+        </p:nvPicPr>
+        <p:blipFill>
+          <a:blip r:embed="rId2"/>
+          <a:stretch>
+            <a:fillRect/>
+          </a:stretch>
+        </p:blipFill>
+        <p:spPr>
+          <a:xfrm>
+            <a:off x="148484" y="1643435"/>
+            <a:ext cx="5315906" cy="4444098"/>
+          </a:xfrm>
+          <a:prstGeom prst="rect">
+            <a:avLst/>
+          </a:prstGeom>
+        </p:spPr>
+      </p:pic>
+    </p:spTree>
+    <p:extLst>
+      <p:ext uri="{BB962C8B-B14F-4D97-AF65-F5344CB8AC3E}">
+        <p14:creationId xmlns:p14="http://schemas.microsoft.com/office/powerpoint/2010/main" val="3780077302"/>
+      </p:ext>
+    </p:extLst>
+  </p:cSld>
+  <p:clrMapOvr>
+    <a:masterClrMapping/>
+  </p:clrMapOvr>
+</p:sld>
+</file>
+
+<file path=ppt/slides/slide11.xml><?xml version="1.0" encoding="utf-8"?>
+<p:sld xmlns:a="http://schemas.openxmlformats.org/drawingml/2006/main" xmlns:r="http://schemas.openxmlformats.org/officeDocument/2006/relationships" xmlns:p="http://schemas.openxmlformats.org/presentationml/2006/main">
+  <p:cSld>
+    <p:spTree>
+      <p:nvGrpSpPr>
+        <p:cNvPr id="1" name=""/>
+        <p:cNvGrpSpPr/>
+        <p:nvPr/>
+      </p:nvGrpSpPr>
+      <p:grpSpPr>
+        <a:xfrm>
+          <a:off x="0" y="0"/>
+          <a:ext cx="0" cy="0"/>
+          <a:chOff x="0" y="0"/>
+          <a:chExt cx="0" cy="0"/>
+        </a:xfrm>
+      </p:grpSpPr>
+      <p:pic>
+        <p:nvPicPr>
+          <p:cNvPr id="5" name="Picture 4" descr="A close-up of a graph&#10;&#10;AI-generated content may be incorrect.">
+            <a:extLst>
+              <a:ext uri="{FF2B5EF4-FFF2-40B4-BE49-F238E27FC236}">
+                <a16:creationId xmlns:a16="http://schemas.microsoft.com/office/drawing/2014/main" id="{19F11027-94DF-DBB2-AC04-B2C469565C7B}"/>
+              </a:ext>
+            </a:extLst>
+          </p:cNvPr>
+          <p:cNvPicPr>
+            <a:picLocks noChangeAspect="1"/>
+          </p:cNvPicPr>
+          <p:nvPr/>
+        </p:nvPicPr>
+        <p:blipFill>
+          <a:blip r:embed="rId2">
+            <a:extLst>
+              <a:ext uri="{28A0092B-C50C-407E-A947-70E740481C1C}">
+                <a14:useLocalDpi xmlns:a14="http://schemas.microsoft.com/office/drawing/2010/main" val="0"/>
+              </a:ext>
+            </a:extLst>
+          </a:blip>
+          <a:stretch>
+            <a:fillRect/>
+          </a:stretch>
+        </p:blipFill>
+        <p:spPr>
+          <a:xfrm>
+            <a:off x="901216" y="0"/>
+            <a:ext cx="10389568" cy="6858000"/>
+          </a:xfrm>
+          <a:prstGeom prst="rect">
+            <a:avLst/>
+          </a:prstGeom>
+        </p:spPr>
+      </p:pic>
+      <p:sp>
+        <p:nvSpPr>
+          <p:cNvPr id="13" name="TextBox 12">
+            <a:extLst>
+              <a:ext uri="{FF2B5EF4-FFF2-40B4-BE49-F238E27FC236}">
+                <a16:creationId xmlns:a16="http://schemas.microsoft.com/office/drawing/2014/main" id="{9C55674A-1AE7-A274-D14D-D0B450A99306}"/>
+              </a:ext>
+            </a:extLst>
+          </p:cNvPr>
+          <p:cNvSpPr txBox="1"/>
+          <p:nvPr/>
+        </p:nvSpPr>
+        <p:spPr>
+          <a:xfrm>
+            <a:off x="696493" y="397933"/>
+            <a:ext cx="548640" cy="584775"/>
+          </a:xfrm>
+          <a:prstGeom prst="rect">
+            <a:avLst/>
+          </a:prstGeom>
+          <a:noFill/>
+        </p:spPr>
+        <p:txBody>
+          <a:bodyPr wrap="square" rtlCol="0">
+            <a:spAutoFit/>
+          </a:bodyPr>
+          <a:lstStyle/>
+          <a:p>
+            <a:r>
+              <a:rPr lang="en-US" sz="3200" b="1" dirty="0"/>
+              <a:t>A</a:t>
+            </a:r>
+          </a:p>
+        </p:txBody>
+      </p:sp>
+      <p:sp>
+        <p:nvSpPr>
+          <p:cNvPr id="14" name="TextBox 13">
+            <a:extLst>
+              <a:ext uri="{FF2B5EF4-FFF2-40B4-BE49-F238E27FC236}">
+                <a16:creationId xmlns:a16="http://schemas.microsoft.com/office/drawing/2014/main" id="{49FD460D-8253-B87A-FB31-8DC99686CD1C}"/>
+              </a:ext>
+            </a:extLst>
+          </p:cNvPr>
+          <p:cNvSpPr txBox="1"/>
+          <p:nvPr/>
+        </p:nvSpPr>
+        <p:spPr>
+          <a:xfrm>
+            <a:off x="5926752" y="397933"/>
+            <a:ext cx="548640" cy="584775"/>
+          </a:xfrm>
+          <a:prstGeom prst="rect">
+            <a:avLst/>
+          </a:prstGeom>
+          <a:noFill/>
+        </p:spPr>
+        <p:txBody>
+          <a:bodyPr wrap="square" rtlCol="0">
+            <a:spAutoFit/>
+          </a:bodyPr>
+          <a:lstStyle/>
+          <a:p>
+            <a:r>
+              <a:rPr lang="en-US" sz="3200" b="1" dirty="0"/>
+              <a:t>B</a:t>
+            </a:r>
+          </a:p>
+        </p:txBody>
+      </p:sp>
+      <p:sp>
+        <p:nvSpPr>
+          <p:cNvPr id="15" name="TextBox 14">
+            <a:extLst>
+              <a:ext uri="{FF2B5EF4-FFF2-40B4-BE49-F238E27FC236}">
+                <a16:creationId xmlns:a16="http://schemas.microsoft.com/office/drawing/2014/main" id="{570D2D0E-090B-6D7F-9F96-E71F2B91F6D4}"/>
+              </a:ext>
+            </a:extLst>
+          </p:cNvPr>
+          <p:cNvSpPr txBox="1"/>
+          <p:nvPr/>
+        </p:nvSpPr>
+        <p:spPr>
+          <a:xfrm>
+            <a:off x="696493" y="3132667"/>
+            <a:ext cx="548640" cy="584775"/>
+          </a:xfrm>
+          <a:prstGeom prst="rect">
+            <a:avLst/>
+          </a:prstGeom>
+          <a:noFill/>
+        </p:spPr>
+        <p:txBody>
+          <a:bodyPr wrap="square" rtlCol="0">
+            <a:spAutoFit/>
+          </a:bodyPr>
+          <a:lstStyle/>
+          <a:p>
+            <a:r>
+              <a:rPr lang="en-US" sz="3200" b="1" dirty="0"/>
+              <a:t>C</a:t>
+            </a:r>
+          </a:p>
+        </p:txBody>
+      </p:sp>
+      <p:sp>
+        <p:nvSpPr>
+          <p:cNvPr id="16" name="TextBox 15">
+            <a:extLst>
+              <a:ext uri="{FF2B5EF4-FFF2-40B4-BE49-F238E27FC236}">
+                <a16:creationId xmlns:a16="http://schemas.microsoft.com/office/drawing/2014/main" id="{95DCE6EB-92A1-C661-5902-B76342434721}"/>
+              </a:ext>
+            </a:extLst>
+          </p:cNvPr>
+          <p:cNvSpPr txBox="1"/>
+          <p:nvPr/>
+        </p:nvSpPr>
+        <p:spPr>
+          <a:xfrm>
+            <a:off x="5926752" y="2937933"/>
+            <a:ext cx="548640" cy="584775"/>
+          </a:xfrm>
+          <a:prstGeom prst="rect">
+            <a:avLst/>
+          </a:prstGeom>
+          <a:noFill/>
+        </p:spPr>
+        <p:txBody>
+          <a:bodyPr wrap="square" rtlCol="0">
+            <a:spAutoFit/>
+          </a:bodyPr>
+          <a:lstStyle/>
+          <a:p>
+            <a:r>
+              <a:rPr lang="en-US" sz="3200" b="1" dirty="0"/>
+              <a:t>D</a:t>
+            </a:r>
+          </a:p>
+        </p:txBody>
+      </p:sp>
+    </p:spTree>
+    <p:extLst>
+      <p:ext uri="{BB962C8B-B14F-4D97-AF65-F5344CB8AC3E}">
+        <p14:creationId xmlns:p14="http://schemas.microsoft.com/office/powerpoint/2010/main" val="1607299825"/>
+      </p:ext>
+    </p:extLst>
+  </p:cSld>
+  <p:clrMapOvr>
+    <a:masterClrMapping/>
+  </p:clrMapOvr>
+</p:sld>
+</file>
+
 <file path=ppt/slides/slide2.xml><?xml version="1.0" encoding="utf-8"?>
 <p:sld xmlns:a="http://schemas.openxmlformats.org/drawingml/2006/main" xmlns:r="http://schemas.openxmlformats.org/officeDocument/2006/relationships" xmlns:p="http://schemas.openxmlformats.org/presentationml/2006/main">
   <p:cSld>
@@ -6368,9 +6766,23 @@
 <file path=ppt/slides/slide8.xml><?xml version="1.0" encoding="utf-8"?>
 <p:sld xmlns:a="http://schemas.openxmlformats.org/drawingml/2006/main" xmlns:r="http://schemas.openxmlformats.org/officeDocument/2006/relationships" xmlns:p="http://schemas.openxmlformats.org/presentationml/2006/main">
   <p:cSld>
+    <p:bg>
+      <p:bgPr>
+        <a:solidFill>
+          <a:schemeClr val="bg1"/>
+        </a:solidFill>
+        <a:effectLst/>
+      </p:bgPr>
+    </p:bg>
     <p:spTree>
       <p:nvGrpSpPr>
-        <p:cNvPr id="1" name=""/>
+        <p:cNvPr id="1" name="">
+          <a:extLst>
+            <a:ext uri="{FF2B5EF4-FFF2-40B4-BE49-F238E27FC236}">
+              <a16:creationId xmlns:a16="http://schemas.microsoft.com/office/drawing/2014/main" id="{9E909C39-4823-BF17-4242-ACDDC0FE386B}"/>
+            </a:ext>
+          </a:extLst>
+        </p:cNvPr>
         <p:cNvGrpSpPr/>
         <p:nvPr/>
       </p:nvGrpSpPr>
@@ -6382,12 +6794,127 @@
           <a:chExt cx="0" cy="0"/>
         </a:xfrm>
       </p:grpSpPr>
+      <p:sp>
+        <p:nvSpPr>
+          <p:cNvPr id="8" name="TextBox 7">
+            <a:extLst>
+              <a:ext uri="{FF2B5EF4-FFF2-40B4-BE49-F238E27FC236}">
+                <a16:creationId xmlns:a16="http://schemas.microsoft.com/office/drawing/2014/main" id="{C1C5A79A-364F-1ADC-B3ED-65F235F5D075}"/>
+              </a:ext>
+            </a:extLst>
+          </p:cNvPr>
+          <p:cNvSpPr txBox="1"/>
+          <p:nvPr/>
+        </p:nvSpPr>
+        <p:spPr>
+          <a:xfrm>
+            <a:off x="314958" y="935548"/>
+            <a:ext cx="548640" cy="707886"/>
+          </a:xfrm>
+          <a:prstGeom prst="rect">
+            <a:avLst/>
+          </a:prstGeom>
+          <a:noFill/>
+        </p:spPr>
+        <p:txBody>
+          <a:bodyPr wrap="square" rtlCol="0">
+            <a:spAutoFit/>
+          </a:bodyPr>
+          <a:lstStyle/>
+          <a:p>
+            <a:r>
+              <a:rPr lang="en-US" sz="4000" b="1" dirty="0"/>
+              <a:t>A</a:t>
+            </a:r>
+          </a:p>
+        </p:txBody>
+      </p:sp>
+      <p:sp>
+        <p:nvSpPr>
+          <p:cNvPr id="9" name="TextBox 8">
+            <a:extLst>
+              <a:ext uri="{FF2B5EF4-FFF2-40B4-BE49-F238E27FC236}">
+                <a16:creationId xmlns:a16="http://schemas.microsoft.com/office/drawing/2014/main" id="{E7BDF677-29C8-7E74-6A28-152963EC02D5}"/>
+              </a:ext>
+            </a:extLst>
+          </p:cNvPr>
+          <p:cNvSpPr txBox="1"/>
+          <p:nvPr/>
+        </p:nvSpPr>
+        <p:spPr>
+          <a:xfrm>
+            <a:off x="5811520" y="935548"/>
+            <a:ext cx="548640" cy="707886"/>
+          </a:xfrm>
+          <a:prstGeom prst="rect">
+            <a:avLst/>
+          </a:prstGeom>
+          <a:noFill/>
+        </p:spPr>
+        <p:txBody>
+          <a:bodyPr wrap="square" rtlCol="0">
+            <a:spAutoFit/>
+          </a:bodyPr>
+          <a:lstStyle/>
+          <a:p>
+            <a:r>
+              <a:rPr lang="en-US" sz="4000" b="1" dirty="0"/>
+              <a:t>B</a:t>
+            </a:r>
+          </a:p>
+        </p:txBody>
+      </p:sp>
+      <p:cxnSp>
+        <p:nvCxnSpPr>
+          <p:cNvPr id="11" name="Straight Connector 10">
+            <a:extLst>
+              <a:ext uri="{FF2B5EF4-FFF2-40B4-BE49-F238E27FC236}">
+                <a16:creationId xmlns:a16="http://schemas.microsoft.com/office/drawing/2014/main" id="{736BB674-6809-B80E-6D44-017C01749D2A}"/>
+              </a:ext>
+            </a:extLst>
+          </p:cNvPr>
+          <p:cNvCxnSpPr/>
+          <p:nvPr/>
+        </p:nvCxnSpPr>
+        <p:spPr>
+          <a:xfrm>
+            <a:off x="5738710" y="558800"/>
+            <a:ext cx="0" cy="5655733"/>
+          </a:xfrm>
+          <a:prstGeom prst="line">
+            <a:avLst/>
+          </a:prstGeom>
+          <a:ln w="19050" cap="flat" cmpd="sng" algn="ctr">
+            <a:solidFill>
+              <a:schemeClr val="dk1"/>
+            </a:solidFill>
+            <a:prstDash val="dash"/>
+            <a:round/>
+            <a:headEnd type="none" w="med" len="med"/>
+            <a:tailEnd type="none" w="med" len="med"/>
+          </a:ln>
+        </p:spPr>
+        <p:style>
+          <a:lnRef idx="0">
+            <a:scrgbClr r="0" g="0" b="0"/>
+          </a:lnRef>
+          <a:fillRef idx="0">
+            <a:scrgbClr r="0" g="0" b="0"/>
+          </a:fillRef>
+          <a:effectRef idx="0">
+            <a:scrgbClr r="0" g="0" b="0"/>
+          </a:effectRef>
+          <a:fontRef idx="minor">
+            <a:schemeClr val="tx1"/>
+          </a:fontRef>
+        </p:style>
+      </p:cxnSp>
       <p:pic>
         <p:nvPicPr>
-          <p:cNvPr id="5" name="Picture 4" descr="A close-up of a graph&#10;&#10;AI-generated content may be incorrect.">
-            <a:extLst>
-              <a:ext uri="{FF2B5EF4-FFF2-40B4-BE49-F238E27FC236}">
-                <a16:creationId xmlns:a16="http://schemas.microsoft.com/office/drawing/2014/main" id="{19F11027-94DF-DBB2-AC04-B2C469565C7B}"/>
+          <p:cNvPr id="4" name="Picture 3">
+            <a:extLst>
+              <a:ext uri="{FF2B5EF4-FFF2-40B4-BE49-F238E27FC236}">
+                <a16:creationId xmlns:a16="http://schemas.microsoft.com/office/drawing/2014/main" id="{B302D493-D75A-BC2B-E8B7-2A76D9099F55}"/>
               </a:ext>
             </a:extLst>
           </p:cNvPr>
@@ -6397,33 +6924,102 @@
           <p:nvPr/>
         </p:nvPicPr>
         <p:blipFill>
-          <a:blip r:embed="rId2">
-            <a:extLst>
-              <a:ext uri="{28A0092B-C50C-407E-A947-70E740481C1C}">
-                <a14:useLocalDpi xmlns:a14="http://schemas.microsoft.com/office/drawing/2010/main" val="0"/>
-              </a:ext>
-            </a:extLst>
-          </a:blip>
+          <a:blip r:embed="rId2"/>
+          <a:srcRect r="5595" b="6495"/>
           <a:stretch>
             <a:fillRect/>
           </a:stretch>
         </p:blipFill>
         <p:spPr>
           <a:xfrm>
-            <a:off x="901216" y="0"/>
-            <a:ext cx="10389568" cy="6858000"/>
+            <a:off x="267547" y="1717369"/>
+            <a:ext cx="5245789" cy="4429429"/>
           </a:xfrm>
           <a:prstGeom prst="rect">
             <a:avLst/>
           </a:prstGeom>
         </p:spPr>
       </p:pic>
-      <p:sp>
-        <p:nvSpPr>
-          <p:cNvPr id="13" name="TextBox 12">
-            <a:extLst>
-              <a:ext uri="{FF2B5EF4-FFF2-40B4-BE49-F238E27FC236}">
-                <a16:creationId xmlns:a16="http://schemas.microsoft.com/office/drawing/2014/main" id="{9C55674A-1AE7-A274-D14D-D0B450A99306}"/>
+      <p:pic>
+        <p:nvPicPr>
+          <p:cNvPr id="7" name="Picture 6">
+            <a:extLst>
+              <a:ext uri="{FF2B5EF4-FFF2-40B4-BE49-F238E27FC236}">
+                <a16:creationId xmlns:a16="http://schemas.microsoft.com/office/drawing/2014/main" id="{C79AAF05-1694-3B40-994F-363AC5DA50B4}"/>
+              </a:ext>
+            </a:extLst>
+          </p:cNvPr>
+          <p:cNvPicPr>
+            <a:picLocks noChangeAspect="1"/>
+          </p:cNvPicPr>
+          <p:nvPr/>
+        </p:nvPicPr>
+        <p:blipFill>
+          <a:blip r:embed="rId3"/>
+          <a:stretch>
+            <a:fillRect/>
+          </a:stretch>
+        </p:blipFill>
+        <p:spPr>
+          <a:xfrm>
+            <a:off x="6252297" y="1708903"/>
+            <a:ext cx="5438478" cy="4429429"/>
+          </a:xfrm>
+          <a:prstGeom prst="rect">
+            <a:avLst/>
+          </a:prstGeom>
+        </p:spPr>
+      </p:pic>
+    </p:spTree>
+    <p:extLst>
+      <p:ext uri="{BB962C8B-B14F-4D97-AF65-F5344CB8AC3E}">
+        <p14:creationId xmlns:p14="http://schemas.microsoft.com/office/powerpoint/2010/main" val="2191162644"/>
+      </p:ext>
+    </p:extLst>
+  </p:cSld>
+  <p:clrMapOvr>
+    <a:masterClrMapping/>
+  </p:clrMapOvr>
+</p:sld>
+</file>
+
+<file path=ppt/slides/slide9.xml><?xml version="1.0" encoding="utf-8"?>
+<p:sld xmlns:a="http://schemas.openxmlformats.org/drawingml/2006/main" xmlns:r="http://schemas.openxmlformats.org/officeDocument/2006/relationships" xmlns:p="http://schemas.openxmlformats.org/presentationml/2006/main">
+  <p:cSld>
+    <p:bg>
+      <p:bgPr>
+        <a:solidFill>
+          <a:schemeClr val="bg1"/>
+        </a:solidFill>
+        <a:effectLst/>
+      </p:bgPr>
+    </p:bg>
+    <p:spTree>
+      <p:nvGrpSpPr>
+        <p:cNvPr id="1" name="">
+          <a:extLst>
+            <a:ext uri="{FF2B5EF4-FFF2-40B4-BE49-F238E27FC236}">
+              <a16:creationId xmlns:a16="http://schemas.microsoft.com/office/drawing/2014/main" id="{CD65EFAD-AE3E-F3F4-8292-1F932C673205}"/>
+            </a:ext>
+          </a:extLst>
+        </p:cNvPr>
+        <p:cNvGrpSpPr/>
+        <p:nvPr/>
+      </p:nvGrpSpPr>
+      <p:grpSpPr>
+        <a:xfrm>
+          <a:off x="0" y="0"/>
+          <a:ext cx="0" cy="0"/>
+          <a:chOff x="0" y="0"/>
+          <a:chExt cx="0" cy="0"/>
+        </a:xfrm>
+      </p:grpSpPr>
+      <p:sp>
+        <p:nvSpPr>
+          <p:cNvPr id="8" name="TextBox 7">
+            <a:extLst>
+              <a:ext uri="{FF2B5EF4-FFF2-40B4-BE49-F238E27FC236}">
+                <a16:creationId xmlns:a16="http://schemas.microsoft.com/office/drawing/2014/main" id="{3711F8F6-D198-937F-DE1B-DD835D20D86D}"/>
               </a:ext>
             </a:extLst>
           </p:cNvPr>
@@ -6432,8 +7028,8 @@
         </p:nvSpPr>
         <p:spPr>
           <a:xfrm>
-            <a:off x="696493" y="397933"/>
-            <a:ext cx="548640" cy="584775"/>
+            <a:off x="314958" y="935548"/>
+            <a:ext cx="548640" cy="707886"/>
           </a:xfrm>
           <a:prstGeom prst="rect">
             <a:avLst/>
@@ -6447,7 +7043,7 @@
           <a:lstStyle/>
           <a:p>
             <a:r>
-              <a:rPr lang="en-US" sz="3200" b="1" dirty="0"/>
+              <a:rPr lang="en-US" sz="4000" b="1" dirty="0"/>
               <a:t>A</a:t>
             </a:r>
           </a:p>
@@ -6455,10 +7051,10 @@
       </p:sp>
       <p:sp>
         <p:nvSpPr>
-          <p:cNvPr id="14" name="TextBox 13">
-            <a:extLst>
-              <a:ext uri="{FF2B5EF4-FFF2-40B4-BE49-F238E27FC236}">
-                <a16:creationId xmlns:a16="http://schemas.microsoft.com/office/drawing/2014/main" id="{49FD460D-8253-B87A-FB31-8DC99686CD1C}"/>
+          <p:cNvPr id="9" name="TextBox 8">
+            <a:extLst>
+              <a:ext uri="{FF2B5EF4-FFF2-40B4-BE49-F238E27FC236}">
+                <a16:creationId xmlns:a16="http://schemas.microsoft.com/office/drawing/2014/main" id="{ED31857F-0C95-8C79-B074-535057B12048}"/>
               </a:ext>
             </a:extLst>
           </p:cNvPr>
@@ -6467,8 +7063,8 @@
         </p:nvSpPr>
         <p:spPr>
           <a:xfrm>
-            <a:off x="5926752" y="397933"/>
-            <a:ext cx="548640" cy="584775"/>
+            <a:off x="5811520" y="935548"/>
+            <a:ext cx="548640" cy="707886"/>
           </a:xfrm>
           <a:prstGeom prst="rect">
             <a:avLst/>
@@ -6482,86 +7078,121 @@
           <a:lstStyle/>
           <a:p>
             <a:r>
-              <a:rPr lang="en-US" sz="3200" b="1" dirty="0"/>
+              <a:rPr lang="en-US" sz="4000" b="1" dirty="0"/>
               <a:t>B</a:t>
             </a:r>
           </a:p>
         </p:txBody>
       </p:sp>
-      <p:sp>
-        <p:nvSpPr>
-          <p:cNvPr id="15" name="TextBox 14">
-            <a:extLst>
-              <a:ext uri="{FF2B5EF4-FFF2-40B4-BE49-F238E27FC236}">
-                <a16:creationId xmlns:a16="http://schemas.microsoft.com/office/drawing/2014/main" id="{570D2D0E-090B-6D7F-9F96-E71F2B91F6D4}"/>
-              </a:ext>
-            </a:extLst>
-          </p:cNvPr>
-          <p:cNvSpPr txBox="1"/>
-          <p:nvPr/>
-        </p:nvSpPr>
-        <p:spPr>
-          <a:xfrm>
-            <a:off x="696493" y="3132667"/>
-            <a:ext cx="548640" cy="584775"/>
-          </a:xfrm>
-          <a:prstGeom prst="rect">
-            <a:avLst/>
-          </a:prstGeom>
-          <a:noFill/>
-        </p:spPr>
-        <p:txBody>
-          <a:bodyPr wrap="square" rtlCol="0">
-            <a:spAutoFit/>
-          </a:bodyPr>
-          <a:lstStyle/>
-          <a:p>
-            <a:r>
-              <a:rPr lang="en-US" sz="3200" b="1" dirty="0"/>
-              <a:t>C</a:t>
-            </a:r>
-          </a:p>
-        </p:txBody>
-      </p:sp>
-      <p:sp>
-        <p:nvSpPr>
-          <p:cNvPr id="16" name="TextBox 15">
-            <a:extLst>
-              <a:ext uri="{FF2B5EF4-FFF2-40B4-BE49-F238E27FC236}">
-                <a16:creationId xmlns:a16="http://schemas.microsoft.com/office/drawing/2014/main" id="{95DCE6EB-92A1-C661-5902-B76342434721}"/>
-              </a:ext>
-            </a:extLst>
-          </p:cNvPr>
-          <p:cNvSpPr txBox="1"/>
-          <p:nvPr/>
-        </p:nvSpPr>
-        <p:spPr>
-          <a:xfrm>
-            <a:off x="5926752" y="2937933"/>
-            <a:ext cx="548640" cy="584775"/>
-          </a:xfrm>
-          <a:prstGeom prst="rect">
-            <a:avLst/>
-          </a:prstGeom>
-          <a:noFill/>
-        </p:spPr>
-        <p:txBody>
-          <a:bodyPr wrap="square" rtlCol="0">
-            <a:spAutoFit/>
-          </a:bodyPr>
-          <a:lstStyle/>
-          <a:p>
-            <a:r>
-              <a:rPr lang="en-US" sz="3200" b="1" dirty="0"/>
-              <a:t>D</a:t>
-            </a:r>
-          </a:p>
-        </p:txBody>
-      </p:sp>
+      <p:cxnSp>
+        <p:nvCxnSpPr>
+          <p:cNvPr id="11" name="Straight Connector 10">
+            <a:extLst>
+              <a:ext uri="{FF2B5EF4-FFF2-40B4-BE49-F238E27FC236}">
+                <a16:creationId xmlns:a16="http://schemas.microsoft.com/office/drawing/2014/main" id="{47677FFC-63C8-9811-2542-E247C7B967D5}"/>
+              </a:ext>
+            </a:extLst>
+          </p:cNvPr>
+          <p:cNvCxnSpPr/>
+          <p:nvPr/>
+        </p:nvCxnSpPr>
+        <p:spPr>
+          <a:xfrm>
+            <a:off x="5738710" y="558800"/>
+            <a:ext cx="0" cy="5655733"/>
+          </a:xfrm>
+          <a:prstGeom prst="line">
+            <a:avLst/>
+          </a:prstGeom>
+          <a:ln w="19050" cap="flat" cmpd="sng" algn="ctr">
+            <a:solidFill>
+              <a:schemeClr val="dk1"/>
+            </a:solidFill>
+            <a:prstDash val="dash"/>
+            <a:round/>
+            <a:headEnd type="none" w="med" len="med"/>
+            <a:tailEnd type="none" w="med" len="med"/>
+          </a:ln>
+        </p:spPr>
+        <p:style>
+          <a:lnRef idx="0">
+            <a:scrgbClr r="0" g="0" b="0"/>
+          </a:lnRef>
+          <a:fillRef idx="0">
+            <a:scrgbClr r="0" g="0" b="0"/>
+          </a:fillRef>
+          <a:effectRef idx="0">
+            <a:scrgbClr r="0" g="0" b="0"/>
+          </a:effectRef>
+          <a:fontRef idx="minor">
+            <a:schemeClr val="tx1"/>
+          </a:fontRef>
+        </p:style>
+      </p:cxnSp>
+      <p:pic>
+        <p:nvPicPr>
+          <p:cNvPr id="3" name="Picture 2">
+            <a:extLst>
+              <a:ext uri="{FF2B5EF4-FFF2-40B4-BE49-F238E27FC236}">
+                <a16:creationId xmlns:a16="http://schemas.microsoft.com/office/drawing/2014/main" id="{17722647-A2B5-B2F5-DA94-71F9FCC0D0E8}"/>
+              </a:ext>
+            </a:extLst>
+          </p:cNvPr>
+          <p:cNvPicPr>
+            <a:picLocks noChangeAspect="1"/>
+          </p:cNvPicPr>
+          <p:nvPr/>
+        </p:nvPicPr>
+        <p:blipFill>
+          <a:blip r:embed="rId2"/>
+          <a:stretch>
+            <a:fillRect/>
+          </a:stretch>
+        </p:blipFill>
+        <p:spPr>
+          <a:xfrm>
+            <a:off x="6360160" y="1643434"/>
+            <a:ext cx="5270569" cy="4359433"/>
+          </a:xfrm>
+          <a:prstGeom prst="rect">
+            <a:avLst/>
+          </a:prstGeom>
+        </p:spPr>
+      </p:pic>
+      <p:pic>
+        <p:nvPicPr>
+          <p:cNvPr id="6" name="Picture 5">
+            <a:extLst>
+              <a:ext uri="{FF2B5EF4-FFF2-40B4-BE49-F238E27FC236}">
+                <a16:creationId xmlns:a16="http://schemas.microsoft.com/office/drawing/2014/main" id="{0176950B-6D82-F64C-249F-1604293148C6}"/>
+              </a:ext>
+            </a:extLst>
+          </p:cNvPr>
+          <p:cNvPicPr>
+            <a:picLocks noChangeAspect="1"/>
+          </p:cNvPicPr>
+          <p:nvPr/>
+        </p:nvPicPr>
+        <p:blipFill>
+          <a:blip r:embed="rId3"/>
+          <a:stretch>
+            <a:fillRect/>
+          </a:stretch>
+        </p:blipFill>
+        <p:spPr>
+          <a:xfrm>
+            <a:off x="243647" y="1702701"/>
+            <a:ext cx="5290098" cy="4359433"/>
+          </a:xfrm>
+          <a:prstGeom prst="rect">
+            <a:avLst/>
+          </a:prstGeom>
+        </p:spPr>
+      </p:pic>
     </p:spTree>
     <p:extLst>
       <p:ext uri="{BB962C8B-B14F-4D97-AF65-F5344CB8AC3E}">
-        <p14:creationId xmlns:p14="http://schemas.microsoft.com/office/powerpoint/2010/main" val="1607299825"/>
+        <p14:creationId xmlns:p14="http://schemas.microsoft.com/office/powerpoint/2010/main" val="809647639"/>
       </p:ext>
     </p:extLst>
   </p:cSld>

</xml_diff>

<commit_message>
change outliers folder location
</commit_message>
<xml_diff>
--- a/Reports/Step1/figures.pptx
+++ b/Reports/Step1/figures.pptx
@@ -8,15 +8,16 @@
     <p:sldId id="256" r:id="rId2"/>
     <p:sldId id="257" r:id="rId3"/>
     <p:sldId id="258" r:id="rId4"/>
-    <p:sldId id="261" r:id="rId5"/>
-    <p:sldId id="262" r:id="rId6"/>
-    <p:sldId id="267" r:id="rId7"/>
-    <p:sldId id="260" r:id="rId8"/>
-    <p:sldId id="259" r:id="rId9"/>
-    <p:sldId id="264" r:id="rId10"/>
-    <p:sldId id="265" r:id="rId11"/>
-    <p:sldId id="266" r:id="rId12"/>
-    <p:sldId id="263" r:id="rId13"/>
+    <p:sldId id="268" r:id="rId5"/>
+    <p:sldId id="261" r:id="rId6"/>
+    <p:sldId id="262" r:id="rId7"/>
+    <p:sldId id="267" r:id="rId8"/>
+    <p:sldId id="260" r:id="rId9"/>
+    <p:sldId id="259" r:id="rId10"/>
+    <p:sldId id="264" r:id="rId11"/>
+    <p:sldId id="265" r:id="rId12"/>
+    <p:sldId id="266" r:id="rId13"/>
+    <p:sldId id="263" r:id="rId14"/>
   </p:sldIdLst>
   <p:sldSz cx="12192000" cy="6858000"/>
   <p:notesSz cx="6858000" cy="9144000"/>
@@ -270,7 +271,7 @@
           <a:p>
             <a:fld id="{070C54B2-02AF-4F32-9526-487D6CDB273B}" type="datetimeFigureOut">
               <a:rPr lang="en-US" smtClean="0"/>
-              <a:t>10/14/2025</a:t>
+              <a:t>10/20/2025</a:t>
             </a:fld>
             <a:endParaRPr lang="en-US"/>
           </a:p>
@@ -468,7 +469,7 @@
           <a:p>
             <a:fld id="{070C54B2-02AF-4F32-9526-487D6CDB273B}" type="datetimeFigureOut">
               <a:rPr lang="en-US" smtClean="0"/>
-              <a:t>10/14/2025</a:t>
+              <a:t>10/20/2025</a:t>
             </a:fld>
             <a:endParaRPr lang="en-US"/>
           </a:p>
@@ -676,7 +677,7 @@
           <a:p>
             <a:fld id="{070C54B2-02AF-4F32-9526-487D6CDB273B}" type="datetimeFigureOut">
               <a:rPr lang="en-US" smtClean="0"/>
-              <a:t>10/14/2025</a:t>
+              <a:t>10/20/2025</a:t>
             </a:fld>
             <a:endParaRPr lang="en-US"/>
           </a:p>
@@ -874,7 +875,7 @@
           <a:p>
             <a:fld id="{070C54B2-02AF-4F32-9526-487D6CDB273B}" type="datetimeFigureOut">
               <a:rPr lang="en-US" smtClean="0"/>
-              <a:t>10/14/2025</a:t>
+              <a:t>10/20/2025</a:t>
             </a:fld>
             <a:endParaRPr lang="en-US"/>
           </a:p>
@@ -1149,7 +1150,7 @@
           <a:p>
             <a:fld id="{070C54B2-02AF-4F32-9526-487D6CDB273B}" type="datetimeFigureOut">
               <a:rPr lang="en-US" smtClean="0"/>
-              <a:t>10/14/2025</a:t>
+              <a:t>10/20/2025</a:t>
             </a:fld>
             <a:endParaRPr lang="en-US"/>
           </a:p>
@@ -1414,7 +1415,7 @@
           <a:p>
             <a:fld id="{070C54B2-02AF-4F32-9526-487D6CDB273B}" type="datetimeFigureOut">
               <a:rPr lang="en-US" smtClean="0"/>
-              <a:t>10/14/2025</a:t>
+              <a:t>10/20/2025</a:t>
             </a:fld>
             <a:endParaRPr lang="en-US"/>
           </a:p>
@@ -1826,7 +1827,7 @@
           <a:p>
             <a:fld id="{070C54B2-02AF-4F32-9526-487D6CDB273B}" type="datetimeFigureOut">
               <a:rPr lang="en-US" smtClean="0"/>
-              <a:t>10/14/2025</a:t>
+              <a:t>10/20/2025</a:t>
             </a:fld>
             <a:endParaRPr lang="en-US"/>
           </a:p>
@@ -1967,7 +1968,7 @@
           <a:p>
             <a:fld id="{070C54B2-02AF-4F32-9526-487D6CDB273B}" type="datetimeFigureOut">
               <a:rPr lang="en-US" smtClean="0"/>
-              <a:t>10/14/2025</a:t>
+              <a:t>10/20/2025</a:t>
             </a:fld>
             <a:endParaRPr lang="en-US"/>
           </a:p>
@@ -2080,7 +2081,7 @@
           <a:p>
             <a:fld id="{070C54B2-02AF-4F32-9526-487D6CDB273B}" type="datetimeFigureOut">
               <a:rPr lang="en-US" smtClean="0"/>
-              <a:t>10/14/2025</a:t>
+              <a:t>10/20/2025</a:t>
             </a:fld>
             <a:endParaRPr lang="en-US"/>
           </a:p>
@@ -2391,7 +2392,7 @@
           <a:p>
             <a:fld id="{070C54B2-02AF-4F32-9526-487D6CDB273B}" type="datetimeFigureOut">
               <a:rPr lang="en-US" smtClean="0"/>
-              <a:t>10/14/2025</a:t>
+              <a:t>10/20/2025</a:t>
             </a:fld>
             <a:endParaRPr lang="en-US"/>
           </a:p>
@@ -2679,7 +2680,7 @@
           <a:p>
             <a:fld id="{070C54B2-02AF-4F32-9526-487D6CDB273B}" type="datetimeFigureOut">
               <a:rPr lang="en-US" smtClean="0"/>
-              <a:t>10/14/2025</a:t>
+              <a:t>10/20/2025</a:t>
             </a:fld>
             <a:endParaRPr lang="en-US"/>
           </a:p>
@@ -2920,7 +2921,7 @@
           <a:p>
             <a:fld id="{070C54B2-02AF-4F32-9526-487D6CDB273B}" type="datetimeFigureOut">
               <a:rPr lang="en-US" smtClean="0"/>
-              <a:t>10/14/2025</a:t>
+              <a:t>10/20/2025</a:t>
             </a:fld>
             <a:endParaRPr lang="en-US"/>
           </a:p>
@@ -3549,6 +3550,226 @@
         <p:cNvPr id="1" name="">
           <a:extLst>
             <a:ext uri="{FF2B5EF4-FFF2-40B4-BE49-F238E27FC236}">
+              <a16:creationId xmlns:a16="http://schemas.microsoft.com/office/drawing/2014/main" id="{9E909C39-4823-BF17-4242-ACDDC0FE386B}"/>
+            </a:ext>
+          </a:extLst>
+        </p:cNvPr>
+        <p:cNvGrpSpPr/>
+        <p:nvPr/>
+      </p:nvGrpSpPr>
+      <p:grpSpPr>
+        <a:xfrm>
+          <a:off x="0" y="0"/>
+          <a:ext cx="0" cy="0"/>
+          <a:chOff x="0" y="0"/>
+          <a:chExt cx="0" cy="0"/>
+        </a:xfrm>
+      </p:grpSpPr>
+      <p:sp>
+        <p:nvSpPr>
+          <p:cNvPr id="8" name="TextBox 7">
+            <a:extLst>
+              <a:ext uri="{FF2B5EF4-FFF2-40B4-BE49-F238E27FC236}">
+                <a16:creationId xmlns:a16="http://schemas.microsoft.com/office/drawing/2014/main" id="{C1C5A79A-364F-1ADC-B3ED-65F235F5D075}"/>
+              </a:ext>
+            </a:extLst>
+          </p:cNvPr>
+          <p:cNvSpPr txBox="1"/>
+          <p:nvPr/>
+        </p:nvSpPr>
+        <p:spPr>
+          <a:xfrm>
+            <a:off x="314958" y="935548"/>
+            <a:ext cx="548640" cy="707886"/>
+          </a:xfrm>
+          <a:prstGeom prst="rect">
+            <a:avLst/>
+          </a:prstGeom>
+          <a:noFill/>
+        </p:spPr>
+        <p:txBody>
+          <a:bodyPr wrap="square" rtlCol="0">
+            <a:spAutoFit/>
+          </a:bodyPr>
+          <a:lstStyle/>
+          <a:p>
+            <a:r>
+              <a:rPr lang="en-US" sz="4000" b="1" dirty="0"/>
+              <a:t>A</a:t>
+            </a:r>
+          </a:p>
+        </p:txBody>
+      </p:sp>
+      <p:sp>
+        <p:nvSpPr>
+          <p:cNvPr id="9" name="TextBox 8">
+            <a:extLst>
+              <a:ext uri="{FF2B5EF4-FFF2-40B4-BE49-F238E27FC236}">
+                <a16:creationId xmlns:a16="http://schemas.microsoft.com/office/drawing/2014/main" id="{E7BDF677-29C8-7E74-6A28-152963EC02D5}"/>
+              </a:ext>
+            </a:extLst>
+          </p:cNvPr>
+          <p:cNvSpPr txBox="1"/>
+          <p:nvPr/>
+        </p:nvSpPr>
+        <p:spPr>
+          <a:xfrm>
+            <a:off x="5811520" y="935548"/>
+            <a:ext cx="548640" cy="707886"/>
+          </a:xfrm>
+          <a:prstGeom prst="rect">
+            <a:avLst/>
+          </a:prstGeom>
+          <a:noFill/>
+        </p:spPr>
+        <p:txBody>
+          <a:bodyPr wrap="square" rtlCol="0">
+            <a:spAutoFit/>
+          </a:bodyPr>
+          <a:lstStyle/>
+          <a:p>
+            <a:r>
+              <a:rPr lang="en-US" sz="4000" b="1" dirty="0"/>
+              <a:t>B</a:t>
+            </a:r>
+          </a:p>
+        </p:txBody>
+      </p:sp>
+      <p:cxnSp>
+        <p:nvCxnSpPr>
+          <p:cNvPr id="11" name="Straight Connector 10">
+            <a:extLst>
+              <a:ext uri="{FF2B5EF4-FFF2-40B4-BE49-F238E27FC236}">
+                <a16:creationId xmlns:a16="http://schemas.microsoft.com/office/drawing/2014/main" id="{736BB674-6809-B80E-6D44-017C01749D2A}"/>
+              </a:ext>
+            </a:extLst>
+          </p:cNvPr>
+          <p:cNvCxnSpPr/>
+          <p:nvPr/>
+        </p:nvCxnSpPr>
+        <p:spPr>
+          <a:xfrm>
+            <a:off x="5738710" y="558800"/>
+            <a:ext cx="0" cy="5655733"/>
+          </a:xfrm>
+          <a:prstGeom prst="line">
+            <a:avLst/>
+          </a:prstGeom>
+          <a:ln w="19050" cap="flat" cmpd="sng" algn="ctr">
+            <a:solidFill>
+              <a:schemeClr val="dk1"/>
+            </a:solidFill>
+            <a:prstDash val="dash"/>
+            <a:round/>
+            <a:headEnd type="none" w="med" len="med"/>
+            <a:tailEnd type="none" w="med" len="med"/>
+          </a:ln>
+        </p:spPr>
+        <p:style>
+          <a:lnRef idx="0">
+            <a:scrgbClr r="0" g="0" b="0"/>
+          </a:lnRef>
+          <a:fillRef idx="0">
+            <a:scrgbClr r="0" g="0" b="0"/>
+          </a:fillRef>
+          <a:effectRef idx="0">
+            <a:scrgbClr r="0" g="0" b="0"/>
+          </a:effectRef>
+          <a:fontRef idx="minor">
+            <a:schemeClr val="tx1"/>
+          </a:fontRef>
+        </p:style>
+      </p:cxnSp>
+      <p:pic>
+        <p:nvPicPr>
+          <p:cNvPr id="4" name="Picture 3">
+            <a:extLst>
+              <a:ext uri="{FF2B5EF4-FFF2-40B4-BE49-F238E27FC236}">
+                <a16:creationId xmlns:a16="http://schemas.microsoft.com/office/drawing/2014/main" id="{B302D493-D75A-BC2B-E8B7-2A76D9099F55}"/>
+              </a:ext>
+            </a:extLst>
+          </p:cNvPr>
+          <p:cNvPicPr>
+            <a:picLocks noChangeAspect="1"/>
+          </p:cNvPicPr>
+          <p:nvPr/>
+        </p:nvPicPr>
+        <p:blipFill>
+          <a:blip r:embed="rId2"/>
+          <a:srcRect r="5595" b="6495"/>
+          <a:stretch>
+            <a:fillRect/>
+          </a:stretch>
+        </p:blipFill>
+        <p:spPr>
+          <a:xfrm>
+            <a:off x="267547" y="1717369"/>
+            <a:ext cx="5245789" cy="4429429"/>
+          </a:xfrm>
+          <a:prstGeom prst="rect">
+            <a:avLst/>
+          </a:prstGeom>
+        </p:spPr>
+      </p:pic>
+      <p:pic>
+        <p:nvPicPr>
+          <p:cNvPr id="7" name="Picture 6">
+            <a:extLst>
+              <a:ext uri="{FF2B5EF4-FFF2-40B4-BE49-F238E27FC236}">
+                <a16:creationId xmlns:a16="http://schemas.microsoft.com/office/drawing/2014/main" id="{C79AAF05-1694-3B40-994F-363AC5DA50B4}"/>
+              </a:ext>
+            </a:extLst>
+          </p:cNvPr>
+          <p:cNvPicPr>
+            <a:picLocks noChangeAspect="1"/>
+          </p:cNvPicPr>
+          <p:nvPr/>
+        </p:nvPicPr>
+        <p:blipFill>
+          <a:blip r:embed="rId3"/>
+          <a:stretch>
+            <a:fillRect/>
+          </a:stretch>
+        </p:blipFill>
+        <p:spPr>
+          <a:xfrm>
+            <a:off x="6252297" y="1708903"/>
+            <a:ext cx="5438478" cy="4429429"/>
+          </a:xfrm>
+          <a:prstGeom prst="rect">
+            <a:avLst/>
+          </a:prstGeom>
+        </p:spPr>
+      </p:pic>
+    </p:spTree>
+    <p:extLst>
+      <p:ext uri="{BB962C8B-B14F-4D97-AF65-F5344CB8AC3E}">
+        <p14:creationId xmlns:p14="http://schemas.microsoft.com/office/powerpoint/2010/main" val="2191162644"/>
+      </p:ext>
+    </p:extLst>
+  </p:cSld>
+  <p:clrMapOvr>
+    <a:masterClrMapping/>
+  </p:clrMapOvr>
+</p:sld>
+</file>
+
+<file path=ppt/slides/slide11.xml><?xml version="1.0" encoding="utf-8"?>
+<p:sld xmlns:a="http://schemas.openxmlformats.org/drawingml/2006/main" xmlns:r="http://schemas.openxmlformats.org/officeDocument/2006/relationships" xmlns:p="http://schemas.openxmlformats.org/presentationml/2006/main">
+  <p:cSld>
+    <p:bg>
+      <p:bgPr>
+        <a:solidFill>
+          <a:schemeClr val="bg1"/>
+        </a:solidFill>
+        <a:effectLst/>
+      </p:bgPr>
+    </p:bg>
+    <p:spTree>
+      <p:nvGrpSpPr>
+        <p:cNvPr id="1" name="">
+          <a:extLst>
+            <a:ext uri="{FF2B5EF4-FFF2-40B4-BE49-F238E27FC236}">
               <a16:creationId xmlns:a16="http://schemas.microsoft.com/office/drawing/2014/main" id="{CD65EFAD-AE3E-F3F4-8292-1F932C673205}"/>
             </a:ext>
           </a:extLst>
@@ -3752,7 +3973,7 @@
 </p:sld>
 </file>
 
-<file path=ppt/slides/slide11.xml><?xml version="1.0" encoding="utf-8"?>
+<file path=ppt/slides/slide12.xml><?xml version="1.0" encoding="utf-8"?>
 <p:sld xmlns:a="http://schemas.openxmlformats.org/drawingml/2006/main" xmlns:r="http://schemas.openxmlformats.org/officeDocument/2006/relationships" xmlns:p="http://schemas.openxmlformats.org/presentationml/2006/main">
   <p:cSld>
     <p:bg>
@@ -3971,7 +4192,7 @@
 </p:sld>
 </file>
 
-<file path=ppt/slides/slide12.xml><?xml version="1.0" encoding="utf-8"?>
+<file path=ppt/slides/slide13.xml><?xml version="1.0" encoding="utf-8"?>
 <p:sld xmlns:a="http://schemas.openxmlformats.org/drawingml/2006/main" xmlns:r="http://schemas.openxmlformats.org/officeDocument/2006/relationships" xmlns:p="http://schemas.openxmlformats.org/presentationml/2006/main">
   <p:cSld>
     <p:spTree>
@@ -3990,7 +4211,7 @@
       </p:grpSpPr>
       <p:pic>
         <p:nvPicPr>
-          <p:cNvPr id="5" name="Picture 4" descr="A close-up of a graph&#10;&#10;AI-generated content may be incorrect.">
+          <p:cNvPr id="5" name="Picture 4">
             <a:extLst>
               <a:ext uri="{FF2B5EF4-FFF2-40B4-BE49-F238E27FC236}">
                 <a16:creationId xmlns:a16="http://schemas.microsoft.com/office/drawing/2014/main" id="{19F11027-94DF-DBB2-AC04-B2C469565C7B}"/>
@@ -4010,14 +4231,13 @@
               </a:ext>
             </a:extLst>
           </a:blip>
-          <a:stretch>
-            <a:fillRect/>
-          </a:stretch>
+          <a:srcRect/>
+          <a:stretch/>
         </p:blipFill>
         <p:spPr>
           <a:xfrm>
             <a:off x="901216" y="0"/>
-            <a:ext cx="10389568" cy="6858000"/>
+            <a:ext cx="10389567" cy="6858000"/>
           </a:xfrm>
           <a:prstGeom prst="rect">
             <a:avLst/>
@@ -5032,6 +5252,428 @@
         <p:cNvPr id="1" name="">
           <a:extLst>
             <a:ext uri="{FF2B5EF4-FFF2-40B4-BE49-F238E27FC236}">
+              <a16:creationId xmlns:a16="http://schemas.microsoft.com/office/drawing/2014/main" id="{6F913BEF-3C04-43D5-7024-263B6CF7F1A9}"/>
+            </a:ext>
+          </a:extLst>
+        </p:cNvPr>
+        <p:cNvGrpSpPr/>
+        <p:nvPr/>
+      </p:nvGrpSpPr>
+      <p:grpSpPr>
+        <a:xfrm>
+          <a:off x="0" y="0"/>
+          <a:ext cx="0" cy="0"/>
+          <a:chOff x="0" y="0"/>
+          <a:chExt cx="0" cy="0"/>
+        </a:xfrm>
+      </p:grpSpPr>
+      <p:sp>
+        <p:nvSpPr>
+          <p:cNvPr id="8" name="TextBox 7">
+            <a:extLst>
+              <a:ext uri="{FF2B5EF4-FFF2-40B4-BE49-F238E27FC236}">
+                <a16:creationId xmlns:a16="http://schemas.microsoft.com/office/drawing/2014/main" id="{7B9EF2FC-A990-D32B-89E9-D50A899FCC47}"/>
+              </a:ext>
+            </a:extLst>
+          </p:cNvPr>
+          <p:cNvSpPr txBox="1"/>
+          <p:nvPr/>
+        </p:nvSpPr>
+        <p:spPr>
+          <a:xfrm>
+            <a:off x="87087" y="0"/>
+            <a:ext cx="548640" cy="584775"/>
+          </a:xfrm>
+          <a:prstGeom prst="rect">
+            <a:avLst/>
+          </a:prstGeom>
+          <a:noFill/>
+        </p:spPr>
+        <p:txBody>
+          <a:bodyPr wrap="square" rtlCol="0">
+            <a:spAutoFit/>
+          </a:bodyPr>
+          <a:lstStyle/>
+          <a:p>
+            <a:r>
+              <a:rPr lang="en-US" sz="3200" b="1" dirty="0"/>
+              <a:t>A</a:t>
+            </a:r>
+          </a:p>
+        </p:txBody>
+      </p:sp>
+      <p:sp>
+        <p:nvSpPr>
+          <p:cNvPr id="9" name="TextBox 8">
+            <a:extLst>
+              <a:ext uri="{FF2B5EF4-FFF2-40B4-BE49-F238E27FC236}">
+                <a16:creationId xmlns:a16="http://schemas.microsoft.com/office/drawing/2014/main" id="{B45820C2-45AA-6942-B395-3B2D8C1FEB1D}"/>
+              </a:ext>
+            </a:extLst>
+          </p:cNvPr>
+          <p:cNvSpPr txBox="1"/>
+          <p:nvPr/>
+        </p:nvSpPr>
+        <p:spPr>
+          <a:xfrm>
+            <a:off x="6135183" y="-17417"/>
+            <a:ext cx="548640" cy="584775"/>
+          </a:xfrm>
+          <a:prstGeom prst="rect">
+            <a:avLst/>
+          </a:prstGeom>
+          <a:noFill/>
+        </p:spPr>
+        <p:txBody>
+          <a:bodyPr wrap="square" rtlCol="0">
+            <a:spAutoFit/>
+          </a:bodyPr>
+          <a:lstStyle/>
+          <a:p>
+            <a:r>
+              <a:rPr lang="en-US" sz="3200" b="1" dirty="0"/>
+              <a:t>B</a:t>
+            </a:r>
+          </a:p>
+        </p:txBody>
+      </p:sp>
+      <p:cxnSp>
+        <p:nvCxnSpPr>
+          <p:cNvPr id="11" name="Straight Connector 10">
+            <a:extLst>
+              <a:ext uri="{FF2B5EF4-FFF2-40B4-BE49-F238E27FC236}">
+                <a16:creationId xmlns:a16="http://schemas.microsoft.com/office/drawing/2014/main" id="{7211B9CD-E25D-E0C9-3062-7B92F237CE5D}"/>
+              </a:ext>
+            </a:extLst>
+          </p:cNvPr>
+          <p:cNvCxnSpPr>
+            <a:cxnSpLocks/>
+          </p:cNvCxnSpPr>
+          <p:nvPr/>
+        </p:nvCxnSpPr>
+        <p:spPr>
+          <a:xfrm>
+            <a:off x="78377" y="3416675"/>
+            <a:ext cx="12192000" cy="24650"/>
+          </a:xfrm>
+          <a:prstGeom prst="line">
+            <a:avLst/>
+          </a:prstGeom>
+          <a:ln w="19050" cap="flat" cmpd="sng" algn="ctr">
+            <a:solidFill>
+              <a:schemeClr val="dk1"/>
+            </a:solidFill>
+            <a:prstDash val="dash"/>
+            <a:round/>
+            <a:headEnd type="none" w="med" len="med"/>
+            <a:tailEnd type="none" w="med" len="med"/>
+          </a:ln>
+        </p:spPr>
+        <p:style>
+          <a:lnRef idx="0">
+            <a:scrgbClr r="0" g="0" b="0"/>
+          </a:lnRef>
+          <a:fillRef idx="0">
+            <a:scrgbClr r="0" g="0" b="0"/>
+          </a:fillRef>
+          <a:effectRef idx="0">
+            <a:scrgbClr r="0" g="0" b="0"/>
+          </a:effectRef>
+          <a:fontRef idx="minor">
+            <a:schemeClr val="tx1"/>
+          </a:fontRef>
+        </p:style>
+      </p:cxnSp>
+      <p:sp>
+        <p:nvSpPr>
+          <p:cNvPr id="21" name="TextBox 20">
+            <a:extLst>
+              <a:ext uri="{FF2B5EF4-FFF2-40B4-BE49-F238E27FC236}">
+                <a16:creationId xmlns:a16="http://schemas.microsoft.com/office/drawing/2014/main" id="{7774763C-189B-9A90-A92D-B78BED01F6A1}"/>
+              </a:ext>
+            </a:extLst>
+          </p:cNvPr>
+          <p:cNvSpPr txBox="1"/>
+          <p:nvPr/>
+        </p:nvSpPr>
+        <p:spPr>
+          <a:xfrm>
+            <a:off x="87087" y="3480782"/>
+            <a:ext cx="548640" cy="584775"/>
+          </a:xfrm>
+          <a:prstGeom prst="rect">
+            <a:avLst/>
+          </a:prstGeom>
+          <a:noFill/>
+        </p:spPr>
+        <p:txBody>
+          <a:bodyPr wrap="square" rtlCol="0">
+            <a:spAutoFit/>
+          </a:bodyPr>
+          <a:lstStyle/>
+          <a:p>
+            <a:r>
+              <a:rPr lang="en-US" sz="3200" b="1" dirty="0"/>
+              <a:t>C</a:t>
+            </a:r>
+          </a:p>
+        </p:txBody>
+      </p:sp>
+      <p:sp>
+        <p:nvSpPr>
+          <p:cNvPr id="22" name="TextBox 21">
+            <a:extLst>
+              <a:ext uri="{FF2B5EF4-FFF2-40B4-BE49-F238E27FC236}">
+                <a16:creationId xmlns:a16="http://schemas.microsoft.com/office/drawing/2014/main" id="{05B305F4-ADA3-C2CC-CF11-113A5B0FE1A5}"/>
+              </a:ext>
+            </a:extLst>
+          </p:cNvPr>
+          <p:cNvSpPr txBox="1"/>
+          <p:nvPr/>
+        </p:nvSpPr>
+        <p:spPr>
+          <a:xfrm>
+            <a:off x="6135183" y="3480782"/>
+            <a:ext cx="548640" cy="584775"/>
+          </a:xfrm>
+          <a:prstGeom prst="rect">
+            <a:avLst/>
+          </a:prstGeom>
+          <a:noFill/>
+        </p:spPr>
+        <p:txBody>
+          <a:bodyPr wrap="square" rtlCol="0">
+            <a:spAutoFit/>
+          </a:bodyPr>
+          <a:lstStyle/>
+          <a:p>
+            <a:r>
+              <a:rPr lang="en-US" sz="3200" b="1" dirty="0"/>
+              <a:t>D</a:t>
+            </a:r>
+          </a:p>
+        </p:txBody>
+      </p:sp>
+      <p:cxnSp>
+        <p:nvCxnSpPr>
+          <p:cNvPr id="26" name="Straight Connector 25">
+            <a:extLst>
+              <a:ext uri="{FF2B5EF4-FFF2-40B4-BE49-F238E27FC236}">
+                <a16:creationId xmlns:a16="http://schemas.microsoft.com/office/drawing/2014/main" id="{2071B693-3BA2-E506-DC8A-010D2F3F764B}"/>
+              </a:ext>
+            </a:extLst>
+          </p:cNvPr>
+          <p:cNvCxnSpPr>
+            <a:cxnSpLocks/>
+          </p:cNvCxnSpPr>
+          <p:nvPr/>
+        </p:nvCxnSpPr>
+        <p:spPr>
+          <a:xfrm>
+            <a:off x="6096000" y="2064"/>
+            <a:ext cx="0" cy="6872867"/>
+          </a:xfrm>
+          <a:prstGeom prst="line">
+            <a:avLst/>
+          </a:prstGeom>
+          <a:ln w="19050" cap="flat" cmpd="sng" algn="ctr">
+            <a:solidFill>
+              <a:schemeClr val="dk1"/>
+            </a:solidFill>
+            <a:prstDash val="dash"/>
+            <a:round/>
+            <a:headEnd type="none" w="med" len="med"/>
+            <a:tailEnd type="none" w="med" len="med"/>
+          </a:ln>
+        </p:spPr>
+        <p:style>
+          <a:lnRef idx="0">
+            <a:scrgbClr r="0" g="0" b="0"/>
+          </a:lnRef>
+          <a:fillRef idx="0">
+            <a:scrgbClr r="0" g="0" b="0"/>
+          </a:fillRef>
+          <a:effectRef idx="0">
+            <a:scrgbClr r="0" g="0" b="0"/>
+          </a:effectRef>
+          <a:fontRef idx="minor">
+            <a:schemeClr val="tx1"/>
+          </a:fontRef>
+        </p:style>
+      </p:cxnSp>
+      <p:pic>
+        <p:nvPicPr>
+          <p:cNvPr id="4" name="Picture 3" descr="A screenshot of a computer&#10;&#10;AI-generated content may be incorrect.">
+            <a:extLst>
+              <a:ext uri="{FF2B5EF4-FFF2-40B4-BE49-F238E27FC236}">
+                <a16:creationId xmlns:a16="http://schemas.microsoft.com/office/drawing/2014/main" id="{9F308971-8116-AD5F-0E54-4B4588584AEC}"/>
+              </a:ext>
+            </a:extLst>
+          </p:cNvPr>
+          <p:cNvPicPr>
+            <a:picLocks noChangeAspect="1"/>
+          </p:cNvPicPr>
+          <p:nvPr/>
+        </p:nvPicPr>
+        <p:blipFill>
+          <a:blip r:embed="rId2">
+            <a:extLst>
+              <a:ext uri="{28A0092B-C50C-407E-A947-70E740481C1C}">
+                <a14:useLocalDpi xmlns:a14="http://schemas.microsoft.com/office/drawing/2010/main" val="0"/>
+              </a:ext>
+            </a:extLst>
+          </a:blip>
+          <a:stretch>
+            <a:fillRect/>
+          </a:stretch>
+        </p:blipFill>
+        <p:spPr>
+          <a:xfrm>
+            <a:off x="554737" y="82908"/>
+            <a:ext cx="5420979" cy="3268649"/>
+          </a:xfrm>
+          <a:prstGeom prst="rect">
+            <a:avLst/>
+          </a:prstGeom>
+        </p:spPr>
+      </p:pic>
+      <p:pic>
+        <p:nvPicPr>
+          <p:cNvPr id="10" name="Picture 9" descr="A screenshot of a computer program&#10;&#10;AI-generated content may be incorrect.">
+            <a:extLst>
+              <a:ext uri="{FF2B5EF4-FFF2-40B4-BE49-F238E27FC236}">
+                <a16:creationId xmlns:a16="http://schemas.microsoft.com/office/drawing/2014/main" id="{D512541B-2C80-FFA1-03A2-E5B0247C8C60}"/>
+              </a:ext>
+            </a:extLst>
+          </p:cNvPr>
+          <p:cNvPicPr>
+            <a:picLocks noChangeAspect="1"/>
+          </p:cNvPicPr>
+          <p:nvPr/>
+        </p:nvPicPr>
+        <p:blipFill>
+          <a:blip r:embed="rId3">
+            <a:extLst>
+              <a:ext uri="{28A0092B-C50C-407E-A947-70E740481C1C}">
+                <a14:useLocalDpi xmlns:a14="http://schemas.microsoft.com/office/drawing/2010/main" val="0"/>
+              </a:ext>
+            </a:extLst>
+          </a:blip>
+          <a:stretch>
+            <a:fillRect/>
+          </a:stretch>
+        </p:blipFill>
+        <p:spPr>
+          <a:xfrm>
+            <a:off x="1080480" y="3532395"/>
+            <a:ext cx="3895315" cy="3290258"/>
+          </a:xfrm>
+          <a:prstGeom prst="rect">
+            <a:avLst/>
+          </a:prstGeom>
+        </p:spPr>
+      </p:pic>
+      <p:pic>
+        <p:nvPicPr>
+          <p:cNvPr id="13" name="Picture 12" descr="A screenshot of a computer&#10;&#10;AI-generated content may be incorrect.">
+            <a:extLst>
+              <a:ext uri="{FF2B5EF4-FFF2-40B4-BE49-F238E27FC236}">
+                <a16:creationId xmlns:a16="http://schemas.microsoft.com/office/drawing/2014/main" id="{CBF8A9AF-91C1-CAD6-B6C6-FF6FF5C294D4}"/>
+              </a:ext>
+            </a:extLst>
+          </p:cNvPr>
+          <p:cNvPicPr>
+            <a:picLocks noChangeAspect="1"/>
+          </p:cNvPicPr>
+          <p:nvPr/>
+        </p:nvPicPr>
+        <p:blipFill>
+          <a:blip r:embed="rId4">
+            <a:extLst>
+              <a:ext uri="{28A0092B-C50C-407E-A947-70E740481C1C}">
+                <a14:useLocalDpi xmlns:a14="http://schemas.microsoft.com/office/drawing/2010/main" val="0"/>
+              </a:ext>
+            </a:extLst>
+          </a:blip>
+          <a:stretch>
+            <a:fillRect/>
+          </a:stretch>
+        </p:blipFill>
+        <p:spPr>
+          <a:xfrm>
+            <a:off x="7035360" y="3505412"/>
+            <a:ext cx="4520914" cy="3317241"/>
+          </a:xfrm>
+          <a:prstGeom prst="rect">
+            <a:avLst/>
+          </a:prstGeom>
+        </p:spPr>
+      </p:pic>
+      <p:pic>
+        <p:nvPicPr>
+          <p:cNvPr id="16" name="Picture 15" descr="A screenshot of a computer&#10;&#10;AI-generated content may be incorrect.">
+            <a:extLst>
+              <a:ext uri="{FF2B5EF4-FFF2-40B4-BE49-F238E27FC236}">
+                <a16:creationId xmlns:a16="http://schemas.microsoft.com/office/drawing/2014/main" id="{C3355F4F-4D5E-8484-C8F2-B2503AB54915}"/>
+              </a:ext>
+            </a:extLst>
+          </p:cNvPr>
+          <p:cNvPicPr>
+            <a:picLocks noChangeAspect="1"/>
+          </p:cNvPicPr>
+          <p:nvPr/>
+        </p:nvPicPr>
+        <p:blipFill>
+          <a:blip r:embed="rId5">
+            <a:extLst>
+              <a:ext uri="{28A0092B-C50C-407E-A947-70E740481C1C}">
+                <a14:useLocalDpi xmlns:a14="http://schemas.microsoft.com/office/drawing/2010/main" val="0"/>
+              </a:ext>
+            </a:extLst>
+          </a:blip>
+          <a:stretch>
+            <a:fillRect/>
+          </a:stretch>
+        </p:blipFill>
+        <p:spPr>
+          <a:xfrm>
+            <a:off x="6696015" y="12194"/>
+            <a:ext cx="4331642" cy="3353624"/>
+          </a:xfrm>
+          <a:prstGeom prst="rect">
+            <a:avLst/>
+          </a:prstGeom>
+        </p:spPr>
+      </p:pic>
+    </p:spTree>
+    <p:extLst>
+      <p:ext uri="{BB962C8B-B14F-4D97-AF65-F5344CB8AC3E}">
+        <p14:creationId xmlns:p14="http://schemas.microsoft.com/office/powerpoint/2010/main" val="1322848941"/>
+      </p:ext>
+    </p:extLst>
+  </p:cSld>
+  <p:clrMapOvr>
+    <a:masterClrMapping/>
+  </p:clrMapOvr>
+</p:sld>
+</file>
+
+<file path=ppt/slides/slide5.xml><?xml version="1.0" encoding="utf-8"?>
+<p:sld xmlns:a="http://schemas.openxmlformats.org/drawingml/2006/main" xmlns:r="http://schemas.openxmlformats.org/officeDocument/2006/relationships" xmlns:p="http://schemas.openxmlformats.org/presentationml/2006/main">
+  <p:cSld>
+    <p:bg>
+      <p:bgPr>
+        <a:solidFill>
+          <a:schemeClr val="bg1"/>
+        </a:solidFill>
+        <a:effectLst/>
+      </p:bgPr>
+    </p:bg>
+    <p:spTree>
+      <p:nvGrpSpPr>
+        <p:cNvPr id="1" name="">
+          <a:extLst>
+            <a:ext uri="{FF2B5EF4-FFF2-40B4-BE49-F238E27FC236}">
               <a16:creationId xmlns:a16="http://schemas.microsoft.com/office/drawing/2014/main" id="{C422BCA4-01DC-B39B-4A07-3D297F6A9221}"/>
             </a:ext>
           </a:extLst>
@@ -5592,7 +6234,7 @@
 </p:sld>
 </file>
 
-<file path=ppt/slides/slide5.xml><?xml version="1.0" encoding="utf-8"?>
+<file path=ppt/slides/slide6.xml><?xml version="1.0" encoding="utf-8"?>
 <p:sld xmlns:a="http://schemas.openxmlformats.org/drawingml/2006/main" xmlns:r="http://schemas.openxmlformats.org/officeDocument/2006/relationships" xmlns:p="http://schemas.openxmlformats.org/presentationml/2006/main">
   <p:cSld>
     <p:bg>
@@ -6165,7 +6807,7 @@
 </p:sld>
 </file>
 
-<file path=ppt/slides/slide6.xml><?xml version="1.0" encoding="utf-8"?>
+<file path=ppt/slides/slide7.xml><?xml version="1.0" encoding="utf-8"?>
 <p:sld xmlns:a="http://schemas.openxmlformats.org/drawingml/2006/main" xmlns:r="http://schemas.openxmlformats.org/officeDocument/2006/relationships" xmlns:p="http://schemas.openxmlformats.org/presentationml/2006/main">
   <p:cSld>
     <p:bg>
@@ -6738,7 +7380,7 @@
 </p:sld>
 </file>
 
-<file path=ppt/slides/slide7.xml><?xml version="1.0" encoding="utf-8"?>
+<file path=ppt/slides/slide8.xml><?xml version="1.0" encoding="utf-8"?>
 <p:sld xmlns:a="http://schemas.openxmlformats.org/drawingml/2006/main" xmlns:r="http://schemas.openxmlformats.org/officeDocument/2006/relationships" xmlns:p="http://schemas.openxmlformats.org/presentationml/2006/main">
   <p:cSld>
     <p:bg>
@@ -7367,7 +8009,7 @@
 </p:sld>
 </file>
 
-<file path=ppt/slides/slide8.xml><?xml version="1.0" encoding="utf-8"?>
+<file path=ppt/slides/slide9.xml><?xml version="1.0" encoding="utf-8"?>
 <p:sld xmlns:a="http://schemas.openxmlformats.org/drawingml/2006/main" xmlns:r="http://schemas.openxmlformats.org/officeDocument/2006/relationships" xmlns:p="http://schemas.openxmlformats.org/presentationml/2006/main">
   <p:cSld>
     <p:bg>
@@ -7577,226 +8219,6 @@
     <p:extLst>
       <p:ext uri="{BB962C8B-B14F-4D97-AF65-F5344CB8AC3E}">
         <p14:creationId xmlns:p14="http://schemas.microsoft.com/office/powerpoint/2010/main" val="286718301"/>
-      </p:ext>
-    </p:extLst>
-  </p:cSld>
-  <p:clrMapOvr>
-    <a:masterClrMapping/>
-  </p:clrMapOvr>
-</p:sld>
-</file>
-
-<file path=ppt/slides/slide9.xml><?xml version="1.0" encoding="utf-8"?>
-<p:sld xmlns:a="http://schemas.openxmlformats.org/drawingml/2006/main" xmlns:r="http://schemas.openxmlformats.org/officeDocument/2006/relationships" xmlns:p="http://schemas.openxmlformats.org/presentationml/2006/main">
-  <p:cSld>
-    <p:bg>
-      <p:bgPr>
-        <a:solidFill>
-          <a:schemeClr val="bg1"/>
-        </a:solidFill>
-        <a:effectLst/>
-      </p:bgPr>
-    </p:bg>
-    <p:spTree>
-      <p:nvGrpSpPr>
-        <p:cNvPr id="1" name="">
-          <a:extLst>
-            <a:ext uri="{FF2B5EF4-FFF2-40B4-BE49-F238E27FC236}">
-              <a16:creationId xmlns:a16="http://schemas.microsoft.com/office/drawing/2014/main" id="{9E909C39-4823-BF17-4242-ACDDC0FE386B}"/>
-            </a:ext>
-          </a:extLst>
-        </p:cNvPr>
-        <p:cNvGrpSpPr/>
-        <p:nvPr/>
-      </p:nvGrpSpPr>
-      <p:grpSpPr>
-        <a:xfrm>
-          <a:off x="0" y="0"/>
-          <a:ext cx="0" cy="0"/>
-          <a:chOff x="0" y="0"/>
-          <a:chExt cx="0" cy="0"/>
-        </a:xfrm>
-      </p:grpSpPr>
-      <p:sp>
-        <p:nvSpPr>
-          <p:cNvPr id="8" name="TextBox 7">
-            <a:extLst>
-              <a:ext uri="{FF2B5EF4-FFF2-40B4-BE49-F238E27FC236}">
-                <a16:creationId xmlns:a16="http://schemas.microsoft.com/office/drawing/2014/main" id="{C1C5A79A-364F-1ADC-B3ED-65F235F5D075}"/>
-              </a:ext>
-            </a:extLst>
-          </p:cNvPr>
-          <p:cNvSpPr txBox="1"/>
-          <p:nvPr/>
-        </p:nvSpPr>
-        <p:spPr>
-          <a:xfrm>
-            <a:off x="314958" y="935548"/>
-            <a:ext cx="548640" cy="707886"/>
-          </a:xfrm>
-          <a:prstGeom prst="rect">
-            <a:avLst/>
-          </a:prstGeom>
-          <a:noFill/>
-        </p:spPr>
-        <p:txBody>
-          <a:bodyPr wrap="square" rtlCol="0">
-            <a:spAutoFit/>
-          </a:bodyPr>
-          <a:lstStyle/>
-          <a:p>
-            <a:r>
-              <a:rPr lang="en-US" sz="4000" b="1" dirty="0"/>
-              <a:t>A</a:t>
-            </a:r>
-          </a:p>
-        </p:txBody>
-      </p:sp>
-      <p:sp>
-        <p:nvSpPr>
-          <p:cNvPr id="9" name="TextBox 8">
-            <a:extLst>
-              <a:ext uri="{FF2B5EF4-FFF2-40B4-BE49-F238E27FC236}">
-                <a16:creationId xmlns:a16="http://schemas.microsoft.com/office/drawing/2014/main" id="{E7BDF677-29C8-7E74-6A28-152963EC02D5}"/>
-              </a:ext>
-            </a:extLst>
-          </p:cNvPr>
-          <p:cNvSpPr txBox="1"/>
-          <p:nvPr/>
-        </p:nvSpPr>
-        <p:spPr>
-          <a:xfrm>
-            <a:off x="5811520" y="935548"/>
-            <a:ext cx="548640" cy="707886"/>
-          </a:xfrm>
-          <a:prstGeom prst="rect">
-            <a:avLst/>
-          </a:prstGeom>
-          <a:noFill/>
-        </p:spPr>
-        <p:txBody>
-          <a:bodyPr wrap="square" rtlCol="0">
-            <a:spAutoFit/>
-          </a:bodyPr>
-          <a:lstStyle/>
-          <a:p>
-            <a:r>
-              <a:rPr lang="en-US" sz="4000" b="1" dirty="0"/>
-              <a:t>B</a:t>
-            </a:r>
-          </a:p>
-        </p:txBody>
-      </p:sp>
-      <p:cxnSp>
-        <p:nvCxnSpPr>
-          <p:cNvPr id="11" name="Straight Connector 10">
-            <a:extLst>
-              <a:ext uri="{FF2B5EF4-FFF2-40B4-BE49-F238E27FC236}">
-                <a16:creationId xmlns:a16="http://schemas.microsoft.com/office/drawing/2014/main" id="{736BB674-6809-B80E-6D44-017C01749D2A}"/>
-              </a:ext>
-            </a:extLst>
-          </p:cNvPr>
-          <p:cNvCxnSpPr/>
-          <p:nvPr/>
-        </p:nvCxnSpPr>
-        <p:spPr>
-          <a:xfrm>
-            <a:off x="5738710" y="558800"/>
-            <a:ext cx="0" cy="5655733"/>
-          </a:xfrm>
-          <a:prstGeom prst="line">
-            <a:avLst/>
-          </a:prstGeom>
-          <a:ln w="19050" cap="flat" cmpd="sng" algn="ctr">
-            <a:solidFill>
-              <a:schemeClr val="dk1"/>
-            </a:solidFill>
-            <a:prstDash val="dash"/>
-            <a:round/>
-            <a:headEnd type="none" w="med" len="med"/>
-            <a:tailEnd type="none" w="med" len="med"/>
-          </a:ln>
-        </p:spPr>
-        <p:style>
-          <a:lnRef idx="0">
-            <a:scrgbClr r="0" g="0" b="0"/>
-          </a:lnRef>
-          <a:fillRef idx="0">
-            <a:scrgbClr r="0" g="0" b="0"/>
-          </a:fillRef>
-          <a:effectRef idx="0">
-            <a:scrgbClr r="0" g="0" b="0"/>
-          </a:effectRef>
-          <a:fontRef idx="minor">
-            <a:schemeClr val="tx1"/>
-          </a:fontRef>
-        </p:style>
-      </p:cxnSp>
-      <p:pic>
-        <p:nvPicPr>
-          <p:cNvPr id="4" name="Picture 3">
-            <a:extLst>
-              <a:ext uri="{FF2B5EF4-FFF2-40B4-BE49-F238E27FC236}">
-                <a16:creationId xmlns:a16="http://schemas.microsoft.com/office/drawing/2014/main" id="{B302D493-D75A-BC2B-E8B7-2A76D9099F55}"/>
-              </a:ext>
-            </a:extLst>
-          </p:cNvPr>
-          <p:cNvPicPr>
-            <a:picLocks noChangeAspect="1"/>
-          </p:cNvPicPr>
-          <p:nvPr/>
-        </p:nvPicPr>
-        <p:blipFill>
-          <a:blip r:embed="rId2"/>
-          <a:srcRect r="5595" b="6495"/>
-          <a:stretch>
-            <a:fillRect/>
-          </a:stretch>
-        </p:blipFill>
-        <p:spPr>
-          <a:xfrm>
-            <a:off x="267547" y="1717369"/>
-            <a:ext cx="5245789" cy="4429429"/>
-          </a:xfrm>
-          <a:prstGeom prst="rect">
-            <a:avLst/>
-          </a:prstGeom>
-        </p:spPr>
-      </p:pic>
-      <p:pic>
-        <p:nvPicPr>
-          <p:cNvPr id="7" name="Picture 6">
-            <a:extLst>
-              <a:ext uri="{FF2B5EF4-FFF2-40B4-BE49-F238E27FC236}">
-                <a16:creationId xmlns:a16="http://schemas.microsoft.com/office/drawing/2014/main" id="{C79AAF05-1694-3B40-994F-363AC5DA50B4}"/>
-              </a:ext>
-            </a:extLst>
-          </p:cNvPr>
-          <p:cNvPicPr>
-            <a:picLocks noChangeAspect="1"/>
-          </p:cNvPicPr>
-          <p:nvPr/>
-        </p:nvPicPr>
-        <p:blipFill>
-          <a:blip r:embed="rId3"/>
-          <a:stretch>
-            <a:fillRect/>
-          </a:stretch>
-        </p:blipFill>
-        <p:spPr>
-          <a:xfrm>
-            <a:off x="6252297" y="1708903"/>
-            <a:ext cx="5438478" cy="4429429"/>
-          </a:xfrm>
-          <a:prstGeom prst="rect">
-            <a:avLst/>
-          </a:prstGeom>
-        </p:spPr>
-      </p:pic>
-    </p:spTree>
-    <p:extLst>
-      <p:ext uri="{BB962C8B-B14F-4D97-AF65-F5344CB8AC3E}">
-        <p14:creationId xmlns:p14="http://schemas.microsoft.com/office/powerpoint/2010/main" val="2191162644"/>
       </p:ext>
     </p:extLst>
   </p:cSld>

</xml_diff>